<commit_message>
Add Faculty Teachers, Teacher Portal, Student Portal with <75% RED Threshold Alert, and UI upgrades
</commit_message>
<xml_diff>
--- a/MarkMate_Project_Presentation.pptx
+++ b/MarkMate_Project_Presentation.pptx
@@ -13,6 +13,7 @@
     <p:sldId id="261" r:id="rId12"/>
     <p:sldId id="262" r:id="rId13"/>
     <p:sldId id="263" r:id="rId14"/>
+    <p:sldId id="264" r:id="rId15"/>
   </p:sldIdLst>
   <p:sldSz cx="12191695" cy="6858000" type="screen4x3"/>
   <p:notesSz cx="6858000" cy="9144000"/>
@@ -3111,8 +3112,8 @@
         </p:nvSpPr>
         <p:spPr>
           <a:xfrm>
-            <a:off x="914400" y="1097280"/>
-            <a:ext cx="10362895" cy="4663440"/>
+            <a:off x="914400" y="1005840"/>
+            <a:ext cx="10362895" cy="4846320"/>
           </a:xfrm>
           <a:prstGeom prst="roundRect">
             <a:avLst/>
@@ -3156,7 +3157,7 @@
         </p:nvSpPr>
         <p:spPr>
           <a:xfrm>
-            <a:off x="1371600" y="1645920"/>
+            <a:off x="1371600" y="1371600"/>
             <a:ext cx="9418320" cy="2011680"/>
           </a:xfrm>
           <a:prstGeom prst="rect">
@@ -3173,7 +3174,7 @@
             <a:pPr>
               <a:defRPr sz="4400" b="1">
                 <a:solidFill>
-                  <a:srgbClr val="0EA5E9"/>
+                  <a:srgbClr val="3B82F6"/>
                 </a:solidFill>
                 <a:latin typeface="Calibri"/>
               </a:defRPr>
@@ -3184,7 +3185,7 @@
           </a:p>
           <a:p>
             <a:pPr>
-              <a:defRPr sz="2600" b="1">
+              <a:defRPr sz="2400" b="1">
                 <a:solidFill>
                   <a:srgbClr val="F1F5F9"/>
                 </a:solidFill>
@@ -3192,15 +3193,15 @@
               </a:defRPr>
             </a:pPr>
             <a:r>
-              <a:t>Modern Student Attendance Management System</a:t>
+              <a:t>Multi-Portal Student Attendance &amp; Department Management System</a:t>
             </a:r>
           </a:p>
           <a:p>
             <a:pPr>
               <a:spcBef>
-                <a:spcPts val="1400"/>
+                <a:spcPts val="1200"/>
               </a:spcBef>
-              <a:defRPr sz="1500">
+              <a:defRPr sz="1400">
                 <a:solidFill>
                   <a:srgbClr val="94A3B8"/>
                 </a:solidFill>
@@ -3208,7 +3209,7 @@
               </a:defRPr>
             </a:pPr>
             <a:r>
-              <a:t>A sleek, automated full-stack web application designed for academic institution attendance tracking &amp; record management.</a:t>
+              <a:t>An automated, full-stack institution portal supporting Civil, Mechanical, Computer Science departments with dedicated Admin, Teacher, and Student portals and automated &lt;75% RED threshold alerts.</a:t>
             </a:r>
           </a:p>
         </p:txBody>
@@ -3221,8 +3222,8 @@
         </p:nvSpPr>
         <p:spPr>
           <a:xfrm>
-            <a:off x="1371600" y="4114800"/>
-            <a:ext cx="9418320" cy="1097280"/>
+            <a:off x="1371600" y="3931920"/>
+            <a:ext cx="9418320" cy="1463040"/>
           </a:xfrm>
           <a:prstGeom prst="rect">
             <a:avLst/>
@@ -3244,7 +3245,23 @@
               </a:defRPr>
             </a:pPr>
             <a:r>
-              <a:t>Tech Stack: Python Flask • SQLAlchemy • MySQL / SQLite • Bootstrap 5</a:t>
+              <a:t>✨ Portals: Admin Dashboard • Teacher Portal (Dept-based) • Student Portal (&lt;75% RED Alert)</a:t>
+            </a:r>
+          </a:p>
+          <a:p>
+            <a:pPr>
+              <a:spcBef>
+                <a:spcPts val="600"/>
+              </a:spcBef>
+              <a:defRPr sz="1300">
+                <a:solidFill>
+                  <a:srgbClr val="94A3B8"/>
+                </a:solidFill>
+                <a:latin typeface="Calibri"/>
+              </a:defRPr>
+            </a:pPr>
+            <a:r>
+              <a:t>🛠️ Tech Stack: Python Flask • SQLAlchemy ORM • Dual MySQL/SQLite • Bootstrap 5 Glassmorphism</a:t>
             </a:r>
           </a:p>
         </p:txBody>
@@ -3300,13 +3317,13 @@
             <a:pPr>
               <a:defRPr sz="1100" b="1">
                 <a:solidFill>
-                  <a:srgbClr val="0EA5E9"/>
+                  <a:srgbClr val="3B82F6"/>
                 </a:solidFill>
                 <a:latin typeface="Calibri"/>
               </a:defRPr>
             </a:pPr>
             <a:r>
-              <a:t>MARKMATE ATTENDANCE SYSTEM</a:t>
+              <a:t>MARKMATE MULTI-PORTAL ATTENDANCE SYSTEM</a:t>
             </a:r>
           </a:p>
         </p:txBody>
@@ -3417,12 +3434,12 @@
             <a:pPr>
               <a:defRPr sz="2000" b="1">
                 <a:solidFill>
-                  <a:srgbClr val="F43F5E"/>
-                </a:solidFill>
-              </a:defRPr>
-            </a:pPr>
-            <a:r>
-              <a:t>❌ Traditional Challenges</a:t>
+                  <a:srgbClr val="EF4444"/>
+                </a:solidFill>
+              </a:defRPr>
+            </a:pPr>
+            <a:r>
+              <a:t>❌ Traditional Academic Challenges</a:t>
             </a:r>
           </a:p>
           <a:p>
@@ -3437,7 +3454,7 @@
               </a:defRPr>
             </a:pPr>
             <a:r>
-              <a:t>• Manual Roll Calls: Time-consuming and takes away valuable lecture time.</a:t>
+              <a:t>• Time-Consuming Roll Calls: Manual registers take away 10-15 minutes of active lecture time.</a:t>
             </a:r>
           </a:p>
           <a:p>
@@ -3452,7 +3469,7 @@
               </a:defRPr>
             </a:pPr>
             <a:r>
-              <a:t>• Human Errors: High risk of miscalculated attendance totals and lost paper registers.</a:t>
+              <a:t>• Lack of Department Isolation: Faculty teachers cannot filter or manage students by Civil, Mechanical, or Computer Science.</a:t>
             </a:r>
           </a:p>
           <a:p>
@@ -3467,7 +3484,7 @@
               </a:defRPr>
             </a:pPr>
             <a:r>
-              <a:t>• Lack of Real-time Visibility: Students and faculty lack instant access to daily presence logs.</a:t>
+              <a:t>• Unaware of Attendance Shortages: Students discover attendance shortages (&lt;75%) too late at exam time.</a:t>
             </a:r>
           </a:p>
           <a:p>
@@ -3482,7 +3499,7 @@
               </a:defRPr>
             </a:pPr>
             <a:r>
-              <a:t>• Audit Difficulties: Searching historical records for specific dates or students is tedious.</a:t>
+              <a:t>• No Centralized Student Visibility: Lack of self-service portals for students to inspect daily attendance history.</a:t>
             </a:r>
           </a:p>
         </p:txBody>
@@ -3577,7 +3594,7 @@
               </a:defRPr>
             </a:pPr>
             <a:r>
-              <a:t>• 1-Click Attendance Marking: Instant interactive radio toggles for fast classroom logging.</a:t>
+              <a:t>• Multi-Role Portals: Role-based access for Admin, Department Teachers, and Students.</a:t>
             </a:r>
           </a:p>
           <a:p>
@@ -3592,7 +3609,7 @@
               </a:defRPr>
             </a:pPr>
             <a:r>
-              <a:t>• Centralized Dashboard: Live visual metric counters for Total, Present, and Absent counts.</a:t>
+              <a:t>• Department-Based Marking: Teachers log in and mark attendance specifically for Civil, ME, CS students.</a:t>
             </a:r>
           </a:p>
           <a:p>
@@ -3607,7 +3624,7 @@
               </a:defRPr>
             </a:pPr>
             <a:r>
-              <a:t>• Duplicate Prevention: Automated database checks prevent double-marking for the same date.</a:t>
+              <a:t>• Automated &lt;75% RED Threshold Alert: Instant red alert card &amp; gauge highlight when student attendance &lt;75%.</a:t>
             </a:r>
           </a:p>
           <a:p>
@@ -3622,7 +3639,7 @@
               </a:defRPr>
             </a:pPr>
             <a:r>
-              <a:t>• Search &amp; Filtering: Filter historical attendance records by student name, roll number, or date.</a:t>
+              <a:t>• Live Dashboard Analytics: Real-time counter metrics, present/absent stats, and exportable logs.</a:t>
             </a:r>
           </a:p>
         </p:txBody>
@@ -3678,13 +3695,13 @@
             <a:pPr>
               <a:defRPr sz="1100" b="1">
                 <a:solidFill>
-                  <a:srgbClr val="0EA5E9"/>
+                  <a:srgbClr val="3B82F6"/>
                 </a:solidFill>
                 <a:latin typeface="Calibri"/>
               </a:defRPr>
             </a:pPr>
             <a:r>
-              <a:t>MARKMATE ATTENDANCE SYSTEM</a:t>
+              <a:t>MARKMATE MULTI-PORTAL ATTENDANCE SYSTEM</a:t>
             </a:r>
           </a:p>
         </p:txBody>
@@ -3720,7 +3737,7 @@
               </a:defRPr>
             </a:pPr>
             <a:r>
-              <a:t>Key Features &amp; Capabilities</a:t>
+              <a:t>Multi-Portal Ecosystem &amp; Access Control</a:t>
             </a:r>
           </a:p>
         </p:txBody>
@@ -3734,7 +3751,7 @@
         <p:spPr>
           <a:xfrm>
             <a:off x="731520" y="1645920"/>
-            <a:ext cx="3383280" cy="2194560"/>
+            <a:ext cx="3383280" cy="4572000"/>
           </a:xfrm>
           <a:prstGeom prst="roundRect">
             <a:avLst/>
@@ -3779,7 +3796,7 @@
         <p:spPr>
           <a:xfrm>
             <a:off x="914400" y="1828800"/>
-            <a:ext cx="3017520" cy="1828800"/>
+            <a:ext cx="3017520" cy="4114800"/>
           </a:xfrm>
           <a:prstGeom prst="rect">
             <a:avLst/>
@@ -3793,20 +3810,35 @@
           <a:lstStyle/>
           <a:p>
             <a:pPr>
-              <a:defRPr sz="1600" b="1">
-                <a:solidFill>
-                  <a:srgbClr val="0EA5E9"/>
-                </a:solidFill>
-              </a:defRPr>
-            </a:pPr>
-            <a:r>
-              <a:t>🔒 Admin Authentication</a:t>
+              <a:defRPr sz="1800" b="1">
+                <a:solidFill>
+                  <a:srgbClr val="3B82F6"/>
+                </a:solidFill>
+              </a:defRPr>
+            </a:pPr>
+            <a:r>
+              <a:t>🛡️ Admin Dashboard</a:t>
             </a:r>
           </a:p>
           <a:p>
             <a:pPr>
               <a:spcBef>
-                <a:spcPts val="800"/>
+                <a:spcPts val="400"/>
+              </a:spcBef>
+              <a:defRPr sz="1200" b="1">
+                <a:solidFill>
+                  <a:srgbClr val="94A3B8"/>
+                </a:solidFill>
+              </a:defRPr>
+            </a:pPr>
+            <a:r>
+              <a:t>Centralized System Management</a:t>
+            </a:r>
+          </a:p>
+          <a:p>
+            <a:pPr>
+              <a:spcBef>
+                <a:spcPts val="1000"/>
               </a:spcBef>
               <a:defRPr sz="1200">
                 <a:solidFill>
@@ -3815,7 +3847,52 @@
               </a:defRPr>
             </a:pPr>
             <a:r>
-              <a:t>Secure login system powered by Werkzeug password hashing session management to safeguard administrative operations.</a:t>
+              <a:t>• Manage faculty teachers (Add/Edit/Delete)</a:t>
+            </a:r>
+          </a:p>
+          <a:p>
+            <a:pPr>
+              <a:spcBef>
+                <a:spcPts val="1000"/>
+              </a:spcBef>
+              <a:defRPr sz="1200">
+                <a:solidFill>
+                  <a:srgbClr val="F1F5F9"/>
+                </a:solidFill>
+              </a:defRPr>
+            </a:pPr>
+            <a:r>
+              <a:t>• Filter students per department (Civil, ME, CS, IT)</a:t>
+            </a:r>
+          </a:p>
+          <a:p>
+            <a:pPr>
+              <a:spcBef>
+                <a:spcPts val="1000"/>
+              </a:spcBef>
+              <a:defRPr sz="1200">
+                <a:solidFill>
+                  <a:srgbClr val="F1F5F9"/>
+                </a:solidFill>
+              </a:defRPr>
+            </a:pPr>
+            <a:r>
+              <a:t>• Department breakdown cards &amp; teacher counts</a:t>
+            </a:r>
+          </a:p>
+          <a:p>
+            <a:pPr>
+              <a:spcBef>
+                <a:spcPts val="1000"/>
+              </a:spcBef>
+              <a:defRPr sz="1200">
+                <a:solidFill>
+                  <a:srgbClr val="F1F5F9"/>
+                </a:solidFill>
+              </a:defRPr>
+            </a:pPr>
+            <a:r>
+              <a:t>• System-wide daily attendance overview</a:t>
             </a:r>
           </a:p>
         </p:txBody>
@@ -3829,7 +3906,7 @@
         <p:spPr>
           <a:xfrm>
             <a:off x="4389120" y="1645920"/>
-            <a:ext cx="3383280" cy="2194560"/>
+            <a:ext cx="3383280" cy="4572000"/>
           </a:xfrm>
           <a:prstGeom prst="roundRect">
             <a:avLst/>
@@ -3874,7 +3951,7 @@
         <p:spPr>
           <a:xfrm>
             <a:off x="4572000" y="1828800"/>
-            <a:ext cx="3017520" cy="1828800"/>
+            <a:ext cx="3017520" cy="4114800"/>
           </a:xfrm>
           <a:prstGeom prst="rect">
             <a:avLst/>
@@ -3888,20 +3965,35 @@
           <a:lstStyle/>
           <a:p>
             <a:pPr>
-              <a:defRPr sz="1600" b="1">
-                <a:solidFill>
-                  <a:srgbClr val="0EA5E9"/>
-                </a:solidFill>
-              </a:defRPr>
-            </a:pPr>
-            <a:r>
-              <a:t>📊 Analytics Dashboard</a:t>
+              <a:defRPr sz="1800" b="1">
+                <a:solidFill>
+                  <a:srgbClr val="6366F1"/>
+                </a:solidFill>
+              </a:defRPr>
+            </a:pPr>
+            <a:r>
+              <a:t>👨‍🏫 Teacher Portal</a:t>
             </a:r>
           </a:p>
           <a:p>
             <a:pPr>
               <a:spcBef>
-                <a:spcPts val="800"/>
+                <a:spcPts val="400"/>
+              </a:spcBef>
+              <a:defRPr sz="1200" b="1">
+                <a:solidFill>
+                  <a:srgbClr val="94A3B8"/>
+                </a:solidFill>
+              </a:defRPr>
+            </a:pPr>
+            <a:r>
+              <a:t>Department-Isolated Interface</a:t>
+            </a:r>
+          </a:p>
+          <a:p>
+            <a:pPr>
+              <a:spcBef>
+                <a:spcPts val="1000"/>
               </a:spcBef>
               <a:defRPr sz="1200">
                 <a:solidFill>
@@ -3910,7 +4002,52 @@
               </a:defRPr>
             </a:pPr>
             <a:r>
-              <a:t>Real-time summary metric cards displaying Total Enrolled Students, Present Today, Absent Today, and latest activity logs.</a:t>
+              <a:t>• Dedicated login for Civil, ME, CS teachers</a:t>
+            </a:r>
+          </a:p>
+          <a:p>
+            <a:pPr>
+              <a:spcBef>
+                <a:spcPts val="1000"/>
+              </a:spcBef>
+              <a:defRPr sz="1200">
+                <a:solidFill>
+                  <a:srgbClr val="F1F5F9"/>
+                </a:solidFill>
+              </a:defRPr>
+            </a:pPr>
+            <a:r>
+              <a:t>• Mark daily attendance for department students</a:t>
+            </a:r>
+          </a:p>
+          <a:p>
+            <a:pPr>
+              <a:spcBef>
+                <a:spcPts val="1000"/>
+              </a:spcBef>
+              <a:defRPr sz="1200">
+                <a:solidFill>
+                  <a:srgbClr val="F1F5F9"/>
+                </a:solidFill>
+              </a:defRPr>
+            </a:pPr>
+            <a:r>
+              <a:t>• Department attendance rate analytics</a:t>
+            </a:r>
+          </a:p>
+          <a:p>
+            <a:pPr>
+              <a:spcBef>
+                <a:spcPts val="1000"/>
+              </a:spcBef>
+              <a:defRPr sz="1200">
+                <a:solidFill>
+                  <a:srgbClr val="F1F5F9"/>
+                </a:solidFill>
+              </a:defRPr>
+            </a:pPr>
+            <a:r>
+              <a:t>• Historical logs filterable by date</a:t>
             </a:r>
           </a:p>
         </p:txBody>
@@ -3924,7 +4061,7 @@
         <p:spPr>
           <a:xfrm>
             <a:off x="8046720" y="1645920"/>
-            <a:ext cx="3383280" cy="2194560"/>
+            <a:ext cx="3383280" cy="4572000"/>
           </a:xfrm>
           <a:prstGeom prst="roundRect">
             <a:avLst/>
@@ -3969,7 +4106,7 @@
         <p:spPr>
           <a:xfrm>
             <a:off x="8229600" y="1828800"/>
-            <a:ext cx="3017520" cy="1828800"/>
+            <a:ext cx="3017520" cy="4114800"/>
           </a:xfrm>
           <a:prstGeom prst="rect">
             <a:avLst/>
@@ -3983,20 +4120,35 @@
           <a:lstStyle/>
           <a:p>
             <a:pPr>
-              <a:defRPr sz="1600" b="1">
-                <a:solidFill>
-                  <a:srgbClr val="0EA5E9"/>
-                </a:solidFill>
-              </a:defRPr>
-            </a:pPr>
-            <a:r>
-              <a:t>👨‍🎓 Student Management</a:t>
+              <a:defRPr sz="1800" b="1">
+                <a:solidFill>
+                  <a:srgbClr val="EF4444"/>
+                </a:solidFill>
+              </a:defRPr>
+            </a:pPr>
+            <a:r>
+              <a:t>🎓 Student Portal</a:t>
             </a:r>
           </a:p>
           <a:p>
             <a:pPr>
               <a:spcBef>
-                <a:spcPts val="800"/>
+                <a:spcPts val="400"/>
+              </a:spcBef>
+              <a:defRPr sz="1200" b="1">
+                <a:solidFill>
+                  <a:srgbClr val="94A3B8"/>
+                </a:solidFill>
+              </a:defRPr>
+            </a:pPr>
+            <a:r>
+              <a:t>Self-Service &amp; Threshold Alert</a:t>
+            </a:r>
+          </a:p>
+          <a:p>
+            <a:pPr>
+              <a:spcBef>
+                <a:spcPts val="1000"/>
               </a:spcBef>
               <a:defRPr sz="1200">
                 <a:solidFill>
@@ -4005,93 +4157,13 @@
               </a:defRPr>
             </a:pPr>
             <a:r>
-              <a:t>Complete CRUD operations: Add new students, edit profiles, search records, and delete with modal confirmation.</a:t>
-            </a:r>
-          </a:p>
-        </p:txBody>
-      </p:sp>
-      <p:sp>
-        <p:nvSpPr>
-          <p:cNvPr id="10" name="Rounded Rectangle 9"/>
-          <p:cNvSpPr/>
-          <p:nvPr/>
-        </p:nvSpPr>
-        <p:spPr>
-          <a:xfrm>
-            <a:off x="731520" y="4114800"/>
-            <a:ext cx="3383280" cy="2194560"/>
-          </a:xfrm>
-          <a:prstGeom prst="roundRect">
-            <a:avLst/>
-          </a:prstGeom>
-          <a:solidFill>
-            <a:srgbClr val="1E293B"/>
-          </a:solidFill>
-          <a:ln>
-            <a:solidFill>
-              <a:srgbClr val="1E293B"/>
-            </a:solidFill>
-          </a:ln>
-        </p:spPr>
-        <p:style>
-          <a:lnRef idx="1">
-            <a:schemeClr val="accent1"/>
-          </a:lnRef>
-          <a:fillRef idx="3">
-            <a:schemeClr val="accent1"/>
-          </a:fillRef>
-          <a:effectRef idx="2">
-            <a:schemeClr val="accent1"/>
-          </a:effectRef>
-          <a:fontRef idx="minor">
-            <a:schemeClr val="lt1"/>
-          </a:fontRef>
-        </p:style>
-        <p:txBody>
-          <a:bodyPr rtlCol="0" anchor="ctr"/>
-          <a:lstStyle/>
-          <a:p>
-            <a:pPr algn="ctr"/>
-          </a:p>
-        </p:txBody>
-      </p:sp>
-      <p:sp>
-        <p:nvSpPr>
-          <p:cNvPr id="11" name="TextBox 10"/>
-          <p:cNvSpPr txBox="1"/>
-          <p:nvPr/>
-        </p:nvSpPr>
-        <p:spPr>
-          <a:xfrm>
-            <a:off x="914400" y="4297680"/>
-            <a:ext cx="3017520" cy="1828800"/>
-          </a:xfrm>
-          <a:prstGeom prst="rect">
-            <a:avLst/>
-          </a:prstGeom>
-          <a:noFill/>
-        </p:spPr>
-        <p:txBody>
-          <a:bodyPr wrap="square">
-            <a:spAutoFit/>
-          </a:bodyPr>
-          <a:lstStyle/>
-          <a:p>
-            <a:pPr>
-              <a:defRPr sz="1600" b="1">
-                <a:solidFill>
-                  <a:srgbClr val="0EA5E9"/>
-                </a:solidFill>
-              </a:defRPr>
-            </a:pPr>
-            <a:r>
-              <a:t>📝 Smart Attendance Marking</a:t>
+              <a:t>• Individual roll number authentication</a:t>
             </a:r>
           </a:p>
           <a:p>
             <a:pPr>
               <a:spcBef>
-                <a:spcPts val="800"/>
+                <a:spcPts val="1000"/>
               </a:spcBef>
               <a:defRPr sz="1200">
                 <a:solidFill>
@@ -4100,93 +4172,13 @@
               </a:defRPr>
             </a:pPr>
             <a:r>
-              <a:t>Auto-loads active students with smart date selection and radio buttons for seamless Present / Absent marking.</a:t>
-            </a:r>
-          </a:p>
-        </p:txBody>
-      </p:sp>
-      <p:sp>
-        <p:nvSpPr>
-          <p:cNvPr id="12" name="Rounded Rectangle 11"/>
-          <p:cNvSpPr/>
-          <p:nvPr/>
-        </p:nvSpPr>
-        <p:spPr>
-          <a:xfrm>
-            <a:off x="4389120" y="4114800"/>
-            <a:ext cx="3383280" cy="2194560"/>
-          </a:xfrm>
-          <a:prstGeom prst="roundRect">
-            <a:avLst/>
-          </a:prstGeom>
-          <a:solidFill>
-            <a:srgbClr val="1E293B"/>
-          </a:solidFill>
-          <a:ln>
-            <a:solidFill>
-              <a:srgbClr val="1E293B"/>
-            </a:solidFill>
-          </a:ln>
-        </p:spPr>
-        <p:style>
-          <a:lnRef idx="1">
-            <a:schemeClr val="accent1"/>
-          </a:lnRef>
-          <a:fillRef idx="3">
-            <a:schemeClr val="accent1"/>
-          </a:fillRef>
-          <a:effectRef idx="2">
-            <a:schemeClr val="accent1"/>
-          </a:effectRef>
-          <a:fontRef idx="minor">
-            <a:schemeClr val="lt1"/>
-          </a:fontRef>
-        </p:style>
-        <p:txBody>
-          <a:bodyPr rtlCol="0" anchor="ctr"/>
-          <a:lstStyle/>
-          <a:p>
-            <a:pPr algn="ctr"/>
-          </a:p>
-        </p:txBody>
-      </p:sp>
-      <p:sp>
-        <p:nvSpPr>
-          <p:cNvPr id="13" name="TextBox 12"/>
-          <p:cNvSpPr txBox="1"/>
-          <p:nvPr/>
-        </p:nvSpPr>
-        <p:spPr>
-          <a:xfrm>
-            <a:off x="4572000" y="4297680"/>
-            <a:ext cx="3017520" cy="1828800"/>
-          </a:xfrm>
-          <a:prstGeom prst="rect">
-            <a:avLst/>
-          </a:prstGeom>
-          <a:noFill/>
-        </p:spPr>
-        <p:txBody>
-          <a:bodyPr wrap="square">
-            <a:spAutoFit/>
-          </a:bodyPr>
-          <a:lstStyle/>
-          <a:p>
-            <a:pPr>
-              <a:defRPr sz="1600" b="1">
-                <a:solidFill>
-                  <a:srgbClr val="0EA5E9"/>
-                </a:solidFill>
-              </a:defRPr>
-            </a:pPr>
-            <a:r>
-              <a:t>🔍 Filterable Attendance Logs</a:t>
+              <a:t>• Overall percentage calculation</a:t>
             </a:r>
           </a:p>
           <a:p>
             <a:pPr>
               <a:spcBef>
-                <a:spcPts val="800"/>
+                <a:spcPts val="1000"/>
               </a:spcBef>
               <a:defRPr sz="1200">
                 <a:solidFill>
@@ -4195,93 +4187,13 @@
               </a:defRPr>
             </a:pPr>
             <a:r>
-              <a:t>Comprehensive historical records table with status badges (Green/Red) and multi-parameter filters.</a:t>
-            </a:r>
-          </a:p>
-        </p:txBody>
-      </p:sp>
-      <p:sp>
-        <p:nvSpPr>
-          <p:cNvPr id="14" name="Rounded Rectangle 13"/>
-          <p:cNvSpPr/>
-          <p:nvPr/>
-        </p:nvSpPr>
-        <p:spPr>
-          <a:xfrm>
-            <a:off x="8046720" y="4114800"/>
-            <a:ext cx="3383280" cy="2194560"/>
-          </a:xfrm>
-          <a:prstGeom prst="roundRect">
-            <a:avLst/>
-          </a:prstGeom>
-          <a:solidFill>
-            <a:srgbClr val="1E293B"/>
-          </a:solidFill>
-          <a:ln>
-            <a:solidFill>
-              <a:srgbClr val="1E293B"/>
-            </a:solidFill>
-          </a:ln>
-        </p:spPr>
-        <p:style>
-          <a:lnRef idx="1">
-            <a:schemeClr val="accent1"/>
-          </a:lnRef>
-          <a:fillRef idx="3">
-            <a:schemeClr val="accent1"/>
-          </a:fillRef>
-          <a:effectRef idx="2">
-            <a:schemeClr val="accent1"/>
-          </a:effectRef>
-          <a:fontRef idx="minor">
-            <a:schemeClr val="lt1"/>
-          </a:fontRef>
-        </p:style>
-        <p:txBody>
-          <a:bodyPr rtlCol="0" anchor="ctr"/>
-          <a:lstStyle/>
-          <a:p>
-            <a:pPr algn="ctr"/>
-          </a:p>
-        </p:txBody>
-      </p:sp>
-      <p:sp>
-        <p:nvSpPr>
-          <p:cNvPr id="15" name="TextBox 14"/>
-          <p:cNvSpPr txBox="1"/>
-          <p:nvPr/>
-        </p:nvSpPr>
-        <p:spPr>
-          <a:xfrm>
-            <a:off x="8229600" y="4297680"/>
-            <a:ext cx="3017520" cy="1828800"/>
-          </a:xfrm>
-          <a:prstGeom prst="rect">
-            <a:avLst/>
-          </a:prstGeom>
-          <a:noFill/>
-        </p:spPr>
-        <p:txBody>
-          <a:bodyPr wrap="square">
-            <a:spAutoFit/>
-          </a:bodyPr>
-          <a:lstStyle/>
-          <a:p>
-            <a:pPr>
-              <a:defRPr sz="1600" b="1">
-                <a:solidFill>
-                  <a:srgbClr val="0EA5E9"/>
-                </a:solidFill>
-              </a:defRPr>
-            </a:pPr>
-            <a:r>
-              <a:t>⚡ Dual Database Architecture</a:t>
+              <a:t>• RED Alert Banner if attendance &lt; 75%</a:t>
             </a:r>
           </a:p>
           <a:p>
             <a:pPr>
               <a:spcBef>
-                <a:spcPts val="800"/>
+                <a:spcPts val="1000"/>
               </a:spcBef>
               <a:defRPr sz="1200">
                 <a:solidFill>
@@ -4290,7 +4202,7 @@
               </a:defRPr>
             </a:pPr>
             <a:r>
-              <a:t>Designed to run seamlessly on production MySQL or instant zero-config fallback on SQLite.</a:t>
+              <a:t>• Full daily attendance record history</a:t>
             </a:r>
           </a:p>
         </p:txBody>
@@ -4346,13 +4258,13 @@
             <a:pPr>
               <a:defRPr sz="1100" b="1">
                 <a:solidFill>
-                  <a:srgbClr val="0EA5E9"/>
+                  <a:srgbClr val="3B82F6"/>
                 </a:solidFill>
                 <a:latin typeface="Calibri"/>
               </a:defRPr>
             </a:pPr>
             <a:r>
-              <a:t>MARKMATE ATTENDANCE SYSTEM</a:t>
+              <a:t>MARKMATE MULTI-PORTAL ATTENDANCE SYSTEM</a:t>
             </a:r>
           </a:p>
         </p:txBody>
@@ -4388,7 +4300,7 @@
               </a:defRPr>
             </a:pPr>
             <a:r>
-              <a:t>Technology Architecture &amp; Stack</a:t>
+              <a:t>Department-Wise Teacher &amp; Student Management</a:t>
             </a:r>
           </a:p>
         </p:txBody>
@@ -4402,7 +4314,7 @@
         <p:spPr>
           <a:xfrm>
             <a:off x="731520" y="1645920"/>
-            <a:ext cx="10698480" cy="1005840"/>
+            <a:ext cx="5120640" cy="2194560"/>
           </a:xfrm>
           <a:prstGeom prst="roundRect">
             <a:avLst/>
@@ -4446,8 +4358,8 @@
         </p:nvSpPr>
         <p:spPr>
           <a:xfrm>
-            <a:off x="1005840" y="1783080"/>
-            <a:ext cx="2926080" cy="731520"/>
+            <a:off x="1005840" y="1874520"/>
+            <a:ext cx="4572000" cy="1737360"/>
           </a:xfrm>
           <a:prstGeom prst="rect">
             <a:avLst/>
@@ -4461,75 +4373,58 @@
           <a:lstStyle/>
           <a:p>
             <a:pPr>
-              <a:defRPr sz="1100" b="1">
-                <a:solidFill>
-                  <a:srgbClr val="0EA5E9"/>
-                </a:solidFill>
-              </a:defRPr>
-            </a:pPr>
-            <a:r>
-              <a:t>BACKEND FRAMEWORK</a:t>
-            </a:r>
-          </a:p>
-          <a:p>
-            <a:pPr>
-              <a:defRPr sz="1600" b="1">
-                <a:solidFill>
-                  <a:srgbClr val="F1F5F9"/>
-                </a:solidFill>
-              </a:defRPr>
-            </a:pPr>
-            <a:r>
-              <a:t>Python 3 &amp; Flask</a:t>
-            </a:r>
-          </a:p>
-        </p:txBody>
-      </p:sp>
-      <p:sp>
-        <p:nvSpPr>
-          <p:cNvPr id="6" name="TextBox 5"/>
-          <p:cNvSpPr txBox="1"/>
-          <p:nvPr/>
-        </p:nvSpPr>
-        <p:spPr>
-          <a:xfrm>
-            <a:off x="4114800" y="1874520"/>
-            <a:ext cx="7040880" cy="640080"/>
-          </a:xfrm>
-          <a:prstGeom prst="rect">
-            <a:avLst/>
-          </a:prstGeom>
-          <a:noFill/>
-        </p:spPr>
-        <p:txBody>
-          <a:bodyPr wrap="square">
-            <a:spAutoFit/>
-          </a:bodyPr>
-          <a:lstStyle/>
-          <a:p>
-            <a:pPr>
-              <a:defRPr sz="1300">
+              <a:defRPr sz="1800" b="1">
+                <a:solidFill>
+                  <a:srgbClr val="3B82F6"/>
+                </a:solidFill>
+              </a:defRPr>
+            </a:pPr>
+            <a:r>
+              <a:t>💻 Computer Science</a:t>
+            </a:r>
+          </a:p>
+          <a:p>
+            <a:pPr>
+              <a:spcBef>
+                <a:spcPts val="600"/>
+              </a:spcBef>
+              <a:defRPr sz="1300" b="1">
+                <a:solidFill>
+                  <a:srgbClr val="10B981"/>
+                </a:solidFill>
+              </a:defRPr>
+            </a:pPr>
+            <a:r>
+              <a:t>Faculty: Prof. Rajesh Sharma &amp; Prof. Vikram Singh</a:t>
+            </a:r>
+          </a:p>
+          <a:p>
+            <a:pPr>
+              <a:spcBef>
+                <a:spcPts val="600"/>
+              </a:spcBef>
+              <a:defRPr sz="1200">
                 <a:solidFill>
                   <a:srgbClr val="94A3B8"/>
                 </a:solidFill>
               </a:defRPr>
             </a:pPr>
             <a:r>
-              <a:t>Flask Blueprints for modular route segregation &amp; clean MVC architecture.</a:t>
-            </a:r>
-          </a:p>
-        </p:txBody>
-      </p:sp>
-      <p:sp>
-        <p:nvSpPr>
-          <p:cNvPr id="7" name="Rounded Rectangle 6"/>
+              <a:t>Manages CS101, CS102, CS103, CS104 student rosters &amp; semester attendance.</a:t>
+            </a:r>
+          </a:p>
+        </p:txBody>
+      </p:sp>
+      <p:sp>
+        <p:nvSpPr>
+          <p:cNvPr id="6" name="Rounded Rectangle 5"/>
           <p:cNvSpPr/>
           <p:nvPr/>
         </p:nvSpPr>
         <p:spPr>
           <a:xfrm>
-            <a:off x="731520" y="2834640"/>
-            <a:ext cx="10698480" cy="1005840"/>
+            <a:off x="6309360" y="1645920"/>
+            <a:ext cx="5120640" cy="2194560"/>
           </a:xfrm>
           <a:prstGeom prst="roundRect">
             <a:avLst/>
@@ -4567,14 +4462,14 @@
       </p:sp>
       <p:sp>
         <p:nvSpPr>
-          <p:cNvPr id="8" name="TextBox 7"/>
+          <p:cNvPr id="7" name="TextBox 6"/>
           <p:cNvSpPr txBox="1"/>
           <p:nvPr/>
         </p:nvSpPr>
         <p:spPr>
           <a:xfrm>
-            <a:off x="1005840" y="2971800"/>
-            <a:ext cx="2926080" cy="731520"/>
+            <a:off x="6583680" y="1874520"/>
+            <a:ext cx="4572000" cy="1737360"/>
           </a:xfrm>
           <a:prstGeom prst="rect">
             <a:avLst/>
@@ -4588,75 +4483,58 @@
           <a:lstStyle/>
           <a:p>
             <a:pPr>
-              <a:defRPr sz="1100" b="1">
+              <a:defRPr sz="1800" b="1">
+                <a:solidFill>
+                  <a:srgbClr val="3B82F6"/>
+                </a:solidFill>
+              </a:defRPr>
+            </a:pPr>
+            <a:r>
+              <a:t>⚙️ Mechanical Engineering</a:t>
+            </a:r>
+          </a:p>
+          <a:p>
+            <a:pPr>
+              <a:spcBef>
+                <a:spcPts val="600"/>
+              </a:spcBef>
+              <a:defRPr sz="1300" b="1">
                 <a:solidFill>
                   <a:srgbClr val="10B981"/>
                 </a:solidFill>
               </a:defRPr>
             </a:pPr>
             <a:r>
-              <a:t>DATABASE &amp; ORM</a:t>
-            </a:r>
-          </a:p>
-          <a:p>
-            <a:pPr>
-              <a:defRPr sz="1600" b="1">
-                <a:solidFill>
-                  <a:srgbClr val="F1F5F9"/>
-                </a:solidFill>
-              </a:defRPr>
-            </a:pPr>
-            <a:r>
-              <a:t>SQLAlchemy &amp; MySQL / SQLite</a:t>
-            </a:r>
-          </a:p>
-        </p:txBody>
-      </p:sp>
-      <p:sp>
-        <p:nvSpPr>
-          <p:cNvPr id="9" name="TextBox 8"/>
-          <p:cNvSpPr txBox="1"/>
-          <p:nvPr/>
-        </p:nvSpPr>
-        <p:spPr>
-          <a:xfrm>
-            <a:off x="4114800" y="3063240"/>
-            <a:ext cx="7040880" cy="640080"/>
-          </a:xfrm>
-          <a:prstGeom prst="rect">
-            <a:avLst/>
-          </a:prstGeom>
-          <a:noFill/>
-        </p:spPr>
-        <p:txBody>
-          <a:bodyPr wrap="square">
-            <a:spAutoFit/>
-          </a:bodyPr>
-          <a:lstStyle/>
-          <a:p>
-            <a:pPr>
-              <a:defRPr sz="1300">
+              <a:t>Faculty: Prof. Suresh Verma</a:t>
+            </a:r>
+          </a:p>
+          <a:p>
+            <a:pPr>
+              <a:spcBef>
+                <a:spcPts val="600"/>
+              </a:spcBef>
+              <a:defRPr sz="1200">
                 <a:solidFill>
                   <a:srgbClr val="94A3B8"/>
                 </a:solidFill>
               </a:defRPr>
             </a:pPr>
             <a:r>
-              <a:t>SQLAlchemy ORM for database abstraction, schema migrations, and relational integrity.</a:t>
-            </a:r>
-          </a:p>
-        </p:txBody>
-      </p:sp>
-      <p:sp>
-        <p:nvSpPr>
-          <p:cNvPr id="10" name="Rounded Rectangle 9"/>
+              <a:t>Manages ME101, ME102 student rosters and laboratory attendance records.</a:t>
+            </a:r>
+          </a:p>
+        </p:txBody>
+      </p:sp>
+      <p:sp>
+        <p:nvSpPr>
+          <p:cNvPr id="8" name="Rounded Rectangle 7"/>
           <p:cNvSpPr/>
           <p:nvPr/>
         </p:nvSpPr>
         <p:spPr>
           <a:xfrm>
-            <a:off x="731520" y="4023360"/>
-            <a:ext cx="10698480" cy="1005840"/>
+            <a:off x="731520" y="4114800"/>
+            <a:ext cx="5120640" cy="2194560"/>
           </a:xfrm>
           <a:prstGeom prst="roundRect">
             <a:avLst/>
@@ -4694,14 +4572,14 @@
       </p:sp>
       <p:sp>
         <p:nvSpPr>
-          <p:cNvPr id="11" name="TextBox 10"/>
+          <p:cNvPr id="9" name="TextBox 8"/>
           <p:cNvSpPr txBox="1"/>
           <p:nvPr/>
         </p:nvSpPr>
         <p:spPr>
           <a:xfrm>
-            <a:off x="1005840" y="4160520"/>
-            <a:ext cx="2926080" cy="731520"/>
+            <a:off x="1005840" y="4343400"/>
+            <a:ext cx="4572000" cy="1737360"/>
           </a:xfrm>
           <a:prstGeom prst="rect">
             <a:avLst/>
@@ -4715,75 +4593,58 @@
           <a:lstStyle/>
           <a:p>
             <a:pPr>
-              <a:defRPr sz="1100" b="1">
-                <a:solidFill>
-                  <a:srgbClr val="F43F5E"/>
-                </a:solidFill>
-              </a:defRPr>
-            </a:pPr>
-            <a:r>
-              <a:t>FRONTEND &amp; STYLING</a:t>
-            </a:r>
-          </a:p>
-          <a:p>
-            <a:pPr>
-              <a:defRPr sz="1600" b="1">
-                <a:solidFill>
-                  <a:srgbClr val="F1F5F9"/>
-                </a:solidFill>
-              </a:defRPr>
-            </a:pPr>
-            <a:r>
-              <a:t>HTML5, CSS3, Bootstrap 5</a:t>
-            </a:r>
-          </a:p>
-        </p:txBody>
-      </p:sp>
-      <p:sp>
-        <p:nvSpPr>
-          <p:cNvPr id="12" name="TextBox 11"/>
-          <p:cNvSpPr txBox="1"/>
-          <p:nvPr/>
-        </p:nvSpPr>
-        <p:spPr>
-          <a:xfrm>
-            <a:off x="4114800" y="4251960"/>
-            <a:ext cx="7040880" cy="640080"/>
-          </a:xfrm>
-          <a:prstGeom prst="rect">
-            <a:avLst/>
-          </a:prstGeom>
-          <a:noFill/>
-        </p:spPr>
-        <p:txBody>
-          <a:bodyPr wrap="square">
-            <a:spAutoFit/>
-          </a:bodyPr>
-          <a:lstStyle/>
-          <a:p>
-            <a:pPr>
-              <a:defRPr sz="1300">
+              <a:defRPr sz="1800" b="1">
+                <a:solidFill>
+                  <a:srgbClr val="3B82F6"/>
+                </a:solidFill>
+              </a:defRPr>
+            </a:pPr>
+            <a:r>
+              <a:t>🏗️ Civil Engineering</a:t>
+            </a:r>
+          </a:p>
+          <a:p>
+            <a:pPr>
+              <a:spcBef>
+                <a:spcPts val="600"/>
+              </a:spcBef>
+              <a:defRPr sz="1300" b="1">
+                <a:solidFill>
+                  <a:srgbClr val="10B981"/>
+                </a:solidFill>
+              </a:defRPr>
+            </a:pPr>
+            <a:r>
+              <a:t>Faculty: Prof. Ananya Gupta</a:t>
+            </a:r>
+          </a:p>
+          <a:p>
+            <a:pPr>
+              <a:spcBef>
+                <a:spcPts val="600"/>
+              </a:spcBef>
+              <a:defRPr sz="1200">
                 <a:solidFill>
                   <a:srgbClr val="94A3B8"/>
                 </a:solidFill>
               </a:defRPr>
             </a:pPr>
             <a:r>
-              <a:t>Modern, responsive UI with customized dark-themed CSS and Bootstrap Icons.</a:t>
-            </a:r>
-          </a:p>
-        </p:txBody>
-      </p:sp>
-      <p:sp>
-        <p:nvSpPr>
-          <p:cNvPr id="13" name="Rounded Rectangle 12"/>
+              <a:t>Manages CE101, CE102 student rosters and structural batch attendance.</a:t>
+            </a:r>
+          </a:p>
+        </p:txBody>
+      </p:sp>
+      <p:sp>
+        <p:nvSpPr>
+          <p:cNvPr id="10" name="Rounded Rectangle 9"/>
           <p:cNvSpPr/>
           <p:nvPr/>
         </p:nvSpPr>
         <p:spPr>
           <a:xfrm>
-            <a:off x="731520" y="5212080"/>
-            <a:ext cx="10698480" cy="1005840"/>
+            <a:off x="6309360" y="4114800"/>
+            <a:ext cx="5120640" cy="2194560"/>
           </a:xfrm>
           <a:prstGeom prst="roundRect">
             <a:avLst/>
@@ -4821,14 +4682,14 @@
       </p:sp>
       <p:sp>
         <p:nvSpPr>
-          <p:cNvPr id="14" name="TextBox 13"/>
+          <p:cNvPr id="11" name="TextBox 10"/>
           <p:cNvSpPr txBox="1"/>
           <p:nvPr/>
         </p:nvSpPr>
         <p:spPr>
           <a:xfrm>
-            <a:off x="1005840" y="5349240"/>
-            <a:ext cx="2926080" cy="731520"/>
+            <a:off x="6583680" y="4343400"/>
+            <a:ext cx="4572000" cy="1737360"/>
           </a:xfrm>
           <a:prstGeom prst="rect">
             <a:avLst/>
@@ -4842,61 +4703,44 @@
           <a:lstStyle/>
           <a:p>
             <a:pPr>
-              <a:defRPr sz="1100" b="1">
-                <a:solidFill>
-                  <a:srgbClr val="0EA5E9"/>
-                </a:solidFill>
-              </a:defRPr>
-            </a:pPr>
-            <a:r>
-              <a:t>SECURITY &amp; AUTH</a:t>
-            </a:r>
-          </a:p>
-          <a:p>
-            <a:pPr>
-              <a:defRPr sz="1600" b="1">
-                <a:solidFill>
-                  <a:srgbClr val="F1F5F9"/>
-                </a:solidFill>
-              </a:defRPr>
-            </a:pPr>
-            <a:r>
-              <a:t>Werkzeug Security &amp; Sessions</a:t>
-            </a:r>
-          </a:p>
-        </p:txBody>
-      </p:sp>
-      <p:sp>
-        <p:nvSpPr>
-          <p:cNvPr id="15" name="TextBox 14"/>
-          <p:cNvSpPr txBox="1"/>
-          <p:nvPr/>
-        </p:nvSpPr>
-        <p:spPr>
-          <a:xfrm>
-            <a:off x="4114800" y="5440680"/>
-            <a:ext cx="7040880" cy="640080"/>
-          </a:xfrm>
-          <a:prstGeom prst="rect">
-            <a:avLst/>
-          </a:prstGeom>
-          <a:noFill/>
-        </p:spPr>
-        <p:txBody>
-          <a:bodyPr wrap="square">
-            <a:spAutoFit/>
-          </a:bodyPr>
-          <a:lstStyle/>
-          <a:p>
-            <a:pPr>
-              <a:defRPr sz="1300">
+              <a:defRPr sz="1800" b="1">
+                <a:solidFill>
+                  <a:srgbClr val="3B82F6"/>
+                </a:solidFill>
+              </a:defRPr>
+            </a:pPr>
+            <a:r>
+              <a:t>🌐 Information Technology</a:t>
+            </a:r>
+          </a:p>
+          <a:p>
+            <a:pPr>
+              <a:spcBef>
+                <a:spcPts val="600"/>
+              </a:spcBef>
+              <a:defRPr sz="1300" b="1">
+                <a:solidFill>
+                  <a:srgbClr val="10B981"/>
+                </a:solidFill>
+              </a:defRPr>
+            </a:pPr>
+            <a:r>
+              <a:t>Faculty: Department Assigned</a:t>
+            </a:r>
+          </a:p>
+          <a:p>
+            <a:pPr>
+              <a:spcBef>
+                <a:spcPts val="600"/>
+              </a:spcBef>
+              <a:defRPr sz="1200">
                 <a:solidFill>
                   <a:srgbClr val="94A3B8"/>
                 </a:solidFill>
               </a:defRPr>
             </a:pPr>
             <a:r>
-              <a:t>Cryptographic password hashing and protected endpoint route decorators.</a:t>
+              <a:t>Manages IT101, IT102, IT103 student rosters and practical sessions.</a:t>
             </a:r>
           </a:p>
         </p:txBody>
@@ -4952,13 +4796,13 @@
             <a:pPr>
               <a:defRPr sz="1100" b="1">
                 <a:solidFill>
-                  <a:srgbClr val="0EA5E9"/>
+                  <a:srgbClr val="3B82F6"/>
                 </a:solidFill>
                 <a:latin typeface="Calibri"/>
               </a:defRPr>
             </a:pPr>
             <a:r>
-              <a:t>MARKMATE ATTENDANCE SYSTEM</a:t>
+              <a:t>MARKMATE MULTI-PORTAL ATTENDANCE SYSTEM</a:t>
             </a:r>
           </a:p>
         </p:txBody>
@@ -4994,7 +4838,7 @@
               </a:defRPr>
             </a:pPr>
             <a:r>
-              <a:t>Database Schema &amp; Entity Models</a:t>
+              <a:t>Automated 75% Attendance Red Threshold Alert</a:t>
             </a:r>
           </a:p>
         </p:txBody>
@@ -5008,7 +4852,7 @@
         <p:spPr>
           <a:xfrm>
             <a:off x="731520" y="1645920"/>
-            <a:ext cx="3383280" cy="4572000"/>
+            <a:ext cx="5120640" cy="4572000"/>
           </a:xfrm>
           <a:prstGeom prst="roundRect">
             <a:avLst/>
@@ -5052,8 +4896,8 @@
         </p:nvSpPr>
         <p:spPr>
           <a:xfrm>
-            <a:off x="914400" y="1828800"/>
-            <a:ext cx="3017520" cy="4114800"/>
+            <a:off x="1005840" y="1920240"/>
+            <a:ext cx="4572000" cy="4023360"/>
           </a:xfrm>
           <a:prstGeom prst="rect">
             <a:avLst/>
@@ -5067,50 +4911,35 @@
           <a:lstStyle/>
           <a:p>
             <a:pPr>
-              <a:defRPr sz="1800" b="1">
-                <a:solidFill>
-                  <a:srgbClr val="0EA5E9"/>
-                </a:solidFill>
-              </a:defRPr>
-            </a:pPr>
-            <a:r>
-              <a:t>Admin Entity</a:t>
+              <a:defRPr sz="2000" b="1">
+                <a:solidFill>
+                  <a:srgbClr val="3B82F6"/>
+                </a:solidFill>
+              </a:defRPr>
+            </a:pPr>
+            <a:r>
+              <a:t>📐 Threshold Calculation Engine</a:t>
             </a:r>
           </a:p>
           <a:p>
             <a:pPr>
               <a:spcBef>
-                <a:spcPts val="400"/>
-              </a:spcBef>
-              <a:defRPr sz="1200" b="1">
-                <a:solidFill>
-                  <a:srgbClr val="94A3B8"/>
-                </a:solidFill>
-              </a:defRPr>
-            </a:pPr>
-            <a:r>
-              <a:t>Table: `admins`</a:t>
-            </a:r>
-          </a:p>
-          <a:p>
-            <a:pPr>
-              <a:spcBef>
-                <a:spcPts val="1400"/>
+                <a:spcPts val="1200"/>
               </a:spcBef>
               <a:defRPr sz="1300" b="1">
                 <a:solidFill>
-                  <a:srgbClr val="F1F5F9"/>
-                </a:solidFill>
-              </a:defRPr>
-            </a:pPr>
-            <a:r>
-              <a:t>Schema Attributes:</a:t>
+                  <a:srgbClr val="10B981"/>
+                </a:solidFill>
+              </a:defRPr>
+            </a:pPr>
+            <a:r>
+              <a:t>Formula: Percentage = (Attended Classes / Total Conducted) * 100</a:t>
             </a:r>
           </a:p>
           <a:p>
             <a:pPr>
               <a:spcBef>
-                <a:spcPts val="600"/>
+                <a:spcPts val="1000"/>
               </a:spcBef>
               <a:defRPr sz="1200">
                 <a:solidFill>
@@ -5119,13 +4948,13 @@
               </a:defRPr>
             </a:pPr>
             <a:r>
-              <a:t>• id (Integer, Primary Key)</a:t>
+              <a:t>• Threshold Rule: If overall attendance &lt; 75.0%, trigger RED Alert UI.</a:t>
             </a:r>
           </a:p>
           <a:p>
             <a:pPr>
               <a:spcBef>
-                <a:spcPts val="600"/>
+                <a:spcPts val="1000"/>
               </a:spcBef>
               <a:defRPr sz="1200">
                 <a:solidFill>
@@ -5134,13 +4963,13 @@
               </a:defRPr>
             </a:pPr>
             <a:r>
-              <a:t>• username (String, Unique)</a:t>
+              <a:t>• Compliant Rule: If overall attendance &gt;= 75.0%, display Green Good Standing.</a:t>
             </a:r>
           </a:p>
           <a:p>
             <a:pPr>
               <a:spcBef>
-                <a:spcPts val="600"/>
+                <a:spcPts val="1000"/>
               </a:spcBef>
               <a:defRPr sz="1200">
                 <a:solidFill>
@@ -5149,13 +4978,13 @@
               </a:defRPr>
             </a:pPr>
             <a:r>
-              <a:t>• password_hash (String)</a:t>
+              <a:t>• Automatic Evaluation: Calculated dynamically on every student dashboard access.</a:t>
             </a:r>
           </a:p>
           <a:p>
             <a:pPr>
               <a:spcBef>
-                <a:spcPts val="600"/>
+                <a:spcPts val="1000"/>
               </a:spcBef>
               <a:defRPr sz="1200">
                 <a:solidFill>
@@ -5164,22 +4993,7 @@
               </a:defRPr>
             </a:pPr>
             <a:r>
-              <a:t>• created_at (DateTime)</a:t>
-            </a:r>
-          </a:p>
-          <a:p>
-            <a:pPr>
-              <a:spcBef>
-                <a:spcPts val="600"/>
-              </a:spcBef>
-              <a:defRPr sz="1200">
-                <a:solidFill>
-                  <a:srgbClr val="F1F5F9"/>
-                </a:solidFill>
-              </a:defRPr>
-            </a:pPr>
-            <a:r>
-              <a:t>• set_password() / check_password()</a:t>
+              <a:t>• Early Intervention: Enables students to take corrective action prior to exam eligibility cutoff.</a:t>
             </a:r>
           </a:p>
         </p:txBody>
@@ -5192,8 +5006,8 @@
         </p:nvSpPr>
         <p:spPr>
           <a:xfrm>
-            <a:off x="4389120" y="1645920"/>
-            <a:ext cx="3383280" cy="4572000"/>
+            <a:off x="6309360" y="1645920"/>
+            <a:ext cx="5120640" cy="4572000"/>
           </a:xfrm>
           <a:prstGeom prst="roundRect">
             <a:avLst/>
@@ -5203,7 +5017,7 @@
           </a:solidFill>
           <a:ln>
             <a:solidFill>
-              <a:srgbClr val="1E293B"/>
+              <a:srgbClr val="EF4444"/>
             </a:solidFill>
           </a:ln>
         </p:spPr>
@@ -5237,8 +5051,8 @@
         </p:nvSpPr>
         <p:spPr>
           <a:xfrm>
-            <a:off x="4572000" y="1828800"/>
-            <a:ext cx="3017520" cy="4114800"/>
+            <a:off x="6583680" y="1920240"/>
+            <a:ext cx="4572000" cy="4023360"/>
           </a:xfrm>
           <a:prstGeom prst="rect">
             <a:avLst/>
@@ -5252,319 +5066,74 @@
           <a:lstStyle/>
           <a:p>
             <a:pPr>
-              <a:defRPr sz="1800" b="1">
-                <a:solidFill>
-                  <a:srgbClr val="10B981"/>
-                </a:solidFill>
-              </a:defRPr>
-            </a:pPr>
-            <a:r>
-              <a:t>Student Entity</a:t>
+              <a:defRPr sz="2000" b="1">
+                <a:solidFill>
+                  <a:srgbClr val="EF4444"/>
+                </a:solidFill>
+              </a:defRPr>
+            </a:pPr>
+            <a:r>
+              <a:t>⚠️ Red Threshold Visual Reaction (&lt; 75%)</a:t>
             </a:r>
           </a:p>
           <a:p>
             <a:pPr>
               <a:spcBef>
-                <a:spcPts val="400"/>
+                <a:spcPts val="1200"/>
               </a:spcBef>
-              <a:defRPr sz="1200" b="1">
-                <a:solidFill>
-                  <a:srgbClr val="94A3B8"/>
-                </a:solidFill>
-              </a:defRPr>
-            </a:pPr>
-            <a:r>
-              <a:t>Table: `students`</a:t>
+              <a:defRPr sz="1300">
+                <a:solidFill>
+                  <a:srgbClr val="F1F5F9"/>
+                </a:solidFill>
+              </a:defRPr>
+            </a:pPr>
+            <a:r>
+              <a:t>1. Pulsing Red Alert Banner: Prominent warning box notifying the exact shortage.</a:t>
             </a:r>
           </a:p>
           <a:p>
             <a:pPr>
               <a:spcBef>
-                <a:spcPts val="1400"/>
+                <a:spcPts val="1200"/>
               </a:spcBef>
-              <a:defRPr sz="1300" b="1">
+              <a:defRPr sz="1300">
                 <a:solidFill>
                   <a:srgbClr val="F1F5F9"/>
                 </a:solidFill>
               </a:defRPr>
             </a:pPr>
             <a:r>
-              <a:t>Schema Attributes:</a:t>
+              <a:t>2. Red Stat Gauge: Stat percentage card highlights in vivid Red (e.g. 33.3%).</a:t>
             </a:r>
           </a:p>
           <a:p>
             <a:pPr>
               <a:spcBef>
-                <a:spcPts val="600"/>
+                <a:spcPts val="1200"/>
               </a:spcBef>
-              <a:defRPr sz="1200">
+              <a:defRPr sz="1300">
                 <a:solidFill>
                   <a:srgbClr val="F1F5F9"/>
                 </a:solidFill>
               </a:defRPr>
             </a:pPr>
             <a:r>
-              <a:t>• id (Integer, Primary Key)</a:t>
+              <a:t>3. Red Progress Bar: High-contrast red bar indicating critical threshold shortage.</a:t>
             </a:r>
           </a:p>
           <a:p>
             <a:pPr>
               <a:spcBef>
-                <a:spcPts val="600"/>
+                <a:spcPts val="1200"/>
               </a:spcBef>
-              <a:defRPr sz="1200">
+              <a:defRPr sz="1300">
                 <a:solidFill>
                   <a:srgbClr val="F1F5F9"/>
                 </a:solidFill>
               </a:defRPr>
             </a:pPr>
             <a:r>
-              <a:t>• roll_number (String, Unique)</a:t>
-            </a:r>
-          </a:p>
-          <a:p>
-            <a:pPr>
-              <a:spcBef>
-                <a:spcPts val="600"/>
-              </a:spcBef>
-              <a:defRPr sz="1200">
-                <a:solidFill>
-                  <a:srgbClr val="F1F5F9"/>
-                </a:solidFill>
-              </a:defRPr>
-            </a:pPr>
-            <a:r>
-              <a:t>• name (String, Not Null)</a:t>
-            </a:r>
-          </a:p>
-          <a:p>
-            <a:pPr>
-              <a:spcBef>
-                <a:spcPts val="600"/>
-              </a:spcBef>
-              <a:defRPr sz="1200">
-                <a:solidFill>
-                  <a:srgbClr val="F1F5F9"/>
-                </a:solidFill>
-              </a:defRPr>
-            </a:pPr>
-            <a:r>
-              <a:t>• department (String)</a:t>
-            </a:r>
-          </a:p>
-          <a:p>
-            <a:pPr>
-              <a:spcBef>
-                <a:spcPts val="600"/>
-              </a:spcBef>
-              <a:defRPr sz="1200">
-                <a:solidFill>
-                  <a:srgbClr val="F1F5F9"/>
-                </a:solidFill>
-              </a:defRPr>
-            </a:pPr>
-            <a:r>
-              <a:t>• semester (String)</a:t>
-            </a:r>
-          </a:p>
-          <a:p>
-            <a:pPr>
-              <a:spcBef>
-                <a:spcPts val="600"/>
-              </a:spcBef>
-              <a:defRPr sz="1200">
-                <a:solidFill>
-                  <a:srgbClr val="F1F5F9"/>
-                </a:solidFill>
-              </a:defRPr>
-            </a:pPr>
-            <a:r>
-              <a:t>• attendance_records (1-to-Many)</a:t>
-            </a:r>
-          </a:p>
-        </p:txBody>
-      </p:sp>
-      <p:sp>
-        <p:nvSpPr>
-          <p:cNvPr id="8" name="Rounded Rectangle 7"/>
-          <p:cNvSpPr/>
-          <p:nvPr/>
-        </p:nvSpPr>
-        <p:spPr>
-          <a:xfrm>
-            <a:off x="8046720" y="1645920"/>
-            <a:ext cx="3383280" cy="4572000"/>
-          </a:xfrm>
-          <a:prstGeom prst="roundRect">
-            <a:avLst/>
-          </a:prstGeom>
-          <a:solidFill>
-            <a:srgbClr val="1E293B"/>
-          </a:solidFill>
-          <a:ln>
-            <a:solidFill>
-              <a:srgbClr val="1E293B"/>
-            </a:solidFill>
-          </a:ln>
-        </p:spPr>
-        <p:style>
-          <a:lnRef idx="1">
-            <a:schemeClr val="accent1"/>
-          </a:lnRef>
-          <a:fillRef idx="3">
-            <a:schemeClr val="accent1"/>
-          </a:fillRef>
-          <a:effectRef idx="2">
-            <a:schemeClr val="accent1"/>
-          </a:effectRef>
-          <a:fontRef idx="minor">
-            <a:schemeClr val="lt1"/>
-          </a:fontRef>
-        </p:style>
-        <p:txBody>
-          <a:bodyPr rtlCol="0" anchor="ctr"/>
-          <a:lstStyle/>
-          <a:p>
-            <a:pPr algn="ctr"/>
-          </a:p>
-        </p:txBody>
-      </p:sp>
-      <p:sp>
-        <p:nvSpPr>
-          <p:cNvPr id="9" name="TextBox 8"/>
-          <p:cNvSpPr txBox="1"/>
-          <p:nvPr/>
-        </p:nvSpPr>
-        <p:spPr>
-          <a:xfrm>
-            <a:off x="8229600" y="1828800"/>
-            <a:ext cx="3017520" cy="4114800"/>
-          </a:xfrm>
-          <a:prstGeom prst="rect">
-            <a:avLst/>
-          </a:prstGeom>
-          <a:noFill/>
-        </p:spPr>
-        <p:txBody>
-          <a:bodyPr wrap="square">
-            <a:spAutoFit/>
-          </a:bodyPr>
-          <a:lstStyle/>
-          <a:p>
-            <a:pPr>
-              <a:defRPr sz="1800" b="1">
-                <a:solidFill>
-                  <a:srgbClr val="F43F5E"/>
-                </a:solidFill>
-              </a:defRPr>
-            </a:pPr>
-            <a:r>
-              <a:t>Attendance Entity</a:t>
-            </a:r>
-          </a:p>
-          <a:p>
-            <a:pPr>
-              <a:spcBef>
-                <a:spcPts val="400"/>
-              </a:spcBef>
-              <a:defRPr sz="1200" b="1">
-                <a:solidFill>
-                  <a:srgbClr val="94A3B8"/>
-                </a:solidFill>
-              </a:defRPr>
-            </a:pPr>
-            <a:r>
-              <a:t>Table: `attendance`</a:t>
-            </a:r>
-          </a:p>
-          <a:p>
-            <a:pPr>
-              <a:spcBef>
-                <a:spcPts val="1400"/>
-              </a:spcBef>
-              <a:defRPr sz="1300" b="1">
-                <a:solidFill>
-                  <a:srgbClr val="F1F5F9"/>
-                </a:solidFill>
-              </a:defRPr>
-            </a:pPr>
-            <a:r>
-              <a:t>Schema Attributes:</a:t>
-            </a:r>
-          </a:p>
-          <a:p>
-            <a:pPr>
-              <a:spcBef>
-                <a:spcPts val="600"/>
-              </a:spcBef>
-              <a:defRPr sz="1200">
-                <a:solidFill>
-                  <a:srgbClr val="F1F5F9"/>
-                </a:solidFill>
-              </a:defRPr>
-            </a:pPr>
-            <a:r>
-              <a:t>• id (Integer, Primary Key)</a:t>
-            </a:r>
-          </a:p>
-          <a:p>
-            <a:pPr>
-              <a:spcBef>
-                <a:spcPts val="600"/>
-              </a:spcBef>
-              <a:defRPr sz="1200">
-                <a:solidFill>
-                  <a:srgbClr val="F1F5F9"/>
-                </a:solidFill>
-              </a:defRPr>
-            </a:pPr>
-            <a:r>
-              <a:t>• student_id (Foreign Key -&gt; students.id)</a:t>
-            </a:r>
-          </a:p>
-          <a:p>
-            <a:pPr>
-              <a:spcBef>
-                <a:spcPts val="600"/>
-              </a:spcBef>
-              <a:defRPr sz="1200">
-                <a:solidFill>
-                  <a:srgbClr val="F1F5F9"/>
-                </a:solidFill>
-              </a:defRPr>
-            </a:pPr>
-            <a:r>
-              <a:t>• attendance_date (Date)</a:t>
-            </a:r>
-          </a:p>
-          <a:p>
-            <a:pPr>
-              <a:spcBef>
-                <a:spcPts val="600"/>
-              </a:spcBef>
-              <a:defRPr sz="1200">
-                <a:solidFill>
-                  <a:srgbClr val="F1F5F9"/>
-                </a:solidFill>
-              </a:defRPr>
-            </a:pPr>
-            <a:r>
-              <a:t>• status ('Present' / 'Absent')</a:t>
-            </a:r>
-          </a:p>
-          <a:p>
-            <a:pPr>
-              <a:spcBef>
-                <a:spcPts val="600"/>
-              </a:spcBef>
-              <a:defRPr sz="1200">
-                <a:solidFill>
-                  <a:srgbClr val="F1F5F9"/>
-                </a:solidFill>
-              </a:defRPr>
-            </a:pPr>
-            <a:r>
-              <a:t>• UniqueConstraint(student_id, date)</a:t>
+              <a:t>4. Badge Highlight: 'Below 75% Threshold' badge displayed on profile header.</a:t>
             </a:r>
           </a:p>
         </p:txBody>
@@ -5620,13 +5189,13 @@
             <a:pPr>
               <a:defRPr sz="1100" b="1">
                 <a:solidFill>
-                  <a:srgbClr val="0EA5E9"/>
+                  <a:srgbClr val="3B82F6"/>
                 </a:solidFill>
                 <a:latin typeface="Calibri"/>
               </a:defRPr>
             </a:pPr>
             <a:r>
-              <a:t>MARKMATE ATTENDANCE SYSTEM</a:t>
+              <a:t>MARKMATE MULTI-PORTAL ATTENDANCE SYSTEM</a:t>
             </a:r>
           </a:p>
         </p:txBody>
@@ -5662,7 +5231,7 @@
               </a:defRPr>
             </a:pPr>
             <a:r>
-              <a:t>System Workflow &amp; User Journey</a:t>
+              <a:t>Technology Architecture &amp; Security Stack</a:t>
             </a:r>
           </a:p>
         </p:txBody>
@@ -5675,8 +5244,8 @@
         </p:nvSpPr>
         <p:spPr>
           <a:xfrm>
-            <a:off x="731520" y="2011680"/>
-            <a:ext cx="2468880" cy="4023360"/>
+            <a:off x="731520" y="1645920"/>
+            <a:ext cx="10698480" cy="1005840"/>
           </a:xfrm>
           <a:prstGeom prst="roundRect">
             <a:avLst/>
@@ -5720,8 +5289,8 @@
         </p:nvSpPr>
         <p:spPr>
           <a:xfrm>
-            <a:off x="868680" y="2194560"/>
-            <a:ext cx="2194560" cy="3657600"/>
+            <a:off x="1005840" y="1783080"/>
+            <a:ext cx="2926080" cy="731520"/>
           </a:xfrm>
           <a:prstGeom prst="rect">
             <a:avLst/>
@@ -5735,43 +5304,75 @@
           <a:lstStyle/>
           <a:p>
             <a:pPr>
-              <a:defRPr sz="1600" b="1">
-                <a:solidFill>
-                  <a:srgbClr val="0EA5E9"/>
-                </a:solidFill>
-              </a:defRPr>
-            </a:pPr>
-            <a:r>
-              <a:t>1. Authentication</a:t>
-            </a:r>
-          </a:p>
-          <a:p>
-            <a:pPr>
-              <a:spcBef>
-                <a:spcPts val="1600"/>
-              </a:spcBef>
+              <a:defRPr sz="1100" b="1">
+                <a:solidFill>
+                  <a:srgbClr val="3B82F6"/>
+                </a:solidFill>
+              </a:defRPr>
+            </a:pPr>
+            <a:r>
+              <a:t>BACKEND FRAMEWORK</a:t>
+            </a:r>
+          </a:p>
+          <a:p>
+            <a:pPr>
+              <a:defRPr sz="1500" b="1">
+                <a:solidFill>
+                  <a:srgbClr val="F1F5F9"/>
+                </a:solidFill>
+              </a:defRPr>
+            </a:pPr>
+            <a:r>
+              <a:t>Python 3 &amp; Flask Framework</a:t>
+            </a:r>
+          </a:p>
+        </p:txBody>
+      </p:sp>
+      <p:sp>
+        <p:nvSpPr>
+          <p:cNvPr id="6" name="TextBox 5"/>
+          <p:cNvSpPr txBox="1"/>
+          <p:nvPr/>
+        </p:nvSpPr>
+        <p:spPr>
+          <a:xfrm>
+            <a:off x="4114800" y="1874520"/>
+            <a:ext cx="7040880" cy="640080"/>
+          </a:xfrm>
+          <a:prstGeom prst="rect">
+            <a:avLst/>
+          </a:prstGeom>
+          <a:noFill/>
+        </p:spPr>
+        <p:txBody>
+          <a:bodyPr wrap="square">
+            <a:spAutoFit/>
+          </a:bodyPr>
+          <a:lstStyle/>
+          <a:p>
+            <a:pPr>
               <a:defRPr sz="1300">
                 <a:solidFill>
-                  <a:srgbClr val="F1F5F9"/>
-                </a:solidFill>
-              </a:defRPr>
-            </a:pPr>
-            <a:r>
-              <a:t>Admin logs into system using hashed credentials via Werkzeug protected auth endpoint.</a:t>
-            </a:r>
-          </a:p>
-        </p:txBody>
-      </p:sp>
-      <p:sp>
-        <p:nvSpPr>
-          <p:cNvPr id="6" name="Rounded Rectangle 5"/>
+                  <a:srgbClr val="94A3B8"/>
+                </a:solidFill>
+              </a:defRPr>
+            </a:pPr>
+            <a:r>
+              <a:t>Flask Blueprints (Auth, Admin, Teachers, Teacher Portal, Student Portal, Attendance).</a:t>
+            </a:r>
+          </a:p>
+        </p:txBody>
+      </p:sp>
+      <p:sp>
+        <p:nvSpPr>
+          <p:cNvPr id="7" name="Rounded Rectangle 6"/>
           <p:cNvSpPr/>
           <p:nvPr/>
         </p:nvSpPr>
         <p:spPr>
           <a:xfrm>
-            <a:off x="3474720" y="2011680"/>
-            <a:ext cx="2468880" cy="4023360"/>
+            <a:off x="731520" y="2834640"/>
+            <a:ext cx="10698480" cy="1005840"/>
           </a:xfrm>
           <a:prstGeom prst="roundRect">
             <a:avLst/>
@@ -5809,14 +5410,14 @@
       </p:sp>
       <p:sp>
         <p:nvSpPr>
-          <p:cNvPr id="7" name="TextBox 6"/>
+          <p:cNvPr id="8" name="TextBox 7"/>
           <p:cNvSpPr txBox="1"/>
           <p:nvPr/>
         </p:nvSpPr>
         <p:spPr>
           <a:xfrm>
-            <a:off x="3611880" y="2194560"/>
-            <a:ext cx="2194560" cy="3657600"/>
+            <a:off x="1005840" y="2971800"/>
+            <a:ext cx="2926080" cy="731520"/>
           </a:xfrm>
           <a:prstGeom prst="rect">
             <a:avLst/>
@@ -5830,43 +5431,75 @@
           <a:lstStyle/>
           <a:p>
             <a:pPr>
-              <a:defRPr sz="1600" b="1">
-                <a:solidFill>
-                  <a:srgbClr val="0EA5E9"/>
-                </a:solidFill>
-              </a:defRPr>
-            </a:pPr>
-            <a:r>
-              <a:t>2. Student Enrollment</a:t>
-            </a:r>
-          </a:p>
-          <a:p>
-            <a:pPr>
-              <a:spcBef>
-                <a:spcPts val="1600"/>
-              </a:spcBef>
+              <a:defRPr sz="1100" b="1">
+                <a:solidFill>
+                  <a:srgbClr val="10B981"/>
+                </a:solidFill>
+              </a:defRPr>
+            </a:pPr>
+            <a:r>
+              <a:t>DATABASE &amp; ORM</a:t>
+            </a:r>
+          </a:p>
+          <a:p>
+            <a:pPr>
+              <a:defRPr sz="1500" b="1">
+                <a:solidFill>
+                  <a:srgbClr val="F1F5F9"/>
+                </a:solidFill>
+              </a:defRPr>
+            </a:pPr>
+            <a:r>
+              <a:t>SQLAlchemy &amp; Dual MySQL/SQLite</a:t>
+            </a:r>
+          </a:p>
+        </p:txBody>
+      </p:sp>
+      <p:sp>
+        <p:nvSpPr>
+          <p:cNvPr id="9" name="TextBox 8"/>
+          <p:cNvSpPr txBox="1"/>
+          <p:nvPr/>
+        </p:nvSpPr>
+        <p:spPr>
+          <a:xfrm>
+            <a:off x="4114800" y="3063240"/>
+            <a:ext cx="7040880" cy="640080"/>
+          </a:xfrm>
+          <a:prstGeom prst="rect">
+            <a:avLst/>
+          </a:prstGeom>
+          <a:noFill/>
+        </p:spPr>
+        <p:txBody>
+          <a:bodyPr wrap="square">
+            <a:spAutoFit/>
+          </a:bodyPr>
+          <a:lstStyle/>
+          <a:p>
+            <a:pPr>
               <a:defRPr sz="1300">
                 <a:solidFill>
-                  <a:srgbClr val="F1F5F9"/>
-                </a:solidFill>
-              </a:defRPr>
-            </a:pPr>
-            <a:r>
-              <a:t>Faculty/Admin registers student profiles with unique Roll Numbers, Department &amp; Semester.</a:t>
-            </a:r>
-          </a:p>
-        </p:txBody>
-      </p:sp>
-      <p:sp>
-        <p:nvSpPr>
-          <p:cNvPr id="8" name="Rounded Rectangle 7"/>
+                  <a:srgbClr val="94A3B8"/>
+                </a:solidFill>
+              </a:defRPr>
+            </a:pPr>
+            <a:r>
+              <a:t>SQLAlchemy ORM with relational foreign key cascading and date uniqueness constraints.</a:t>
+            </a:r>
+          </a:p>
+        </p:txBody>
+      </p:sp>
+      <p:sp>
+        <p:nvSpPr>
+          <p:cNvPr id="10" name="Rounded Rectangle 9"/>
           <p:cNvSpPr/>
           <p:nvPr/>
         </p:nvSpPr>
         <p:spPr>
           <a:xfrm>
-            <a:off x="6217920" y="2011680"/>
-            <a:ext cx="2468880" cy="4023360"/>
+            <a:off x="731520" y="4023360"/>
+            <a:ext cx="10698480" cy="1005840"/>
           </a:xfrm>
           <a:prstGeom prst="roundRect">
             <a:avLst/>
@@ -5904,14 +5537,14 @@
       </p:sp>
       <p:sp>
         <p:nvSpPr>
-          <p:cNvPr id="9" name="TextBox 8"/>
+          <p:cNvPr id="11" name="TextBox 10"/>
           <p:cNvSpPr txBox="1"/>
           <p:nvPr/>
         </p:nvSpPr>
         <p:spPr>
           <a:xfrm>
-            <a:off x="6355080" y="2194560"/>
-            <a:ext cx="2194560" cy="3657600"/>
+            <a:off x="1005840" y="4160520"/>
+            <a:ext cx="2926080" cy="731520"/>
           </a:xfrm>
           <a:prstGeom prst="rect">
             <a:avLst/>
@@ -5925,43 +5558,75 @@
           <a:lstStyle/>
           <a:p>
             <a:pPr>
-              <a:defRPr sz="1600" b="1">
-                <a:solidFill>
-                  <a:srgbClr val="0EA5E9"/>
-                </a:solidFill>
-              </a:defRPr>
-            </a:pPr>
-            <a:r>
-              <a:t>3. Attendance Entry</a:t>
-            </a:r>
-          </a:p>
-          <a:p>
-            <a:pPr>
-              <a:spcBef>
-                <a:spcPts val="1600"/>
-              </a:spcBef>
+              <a:defRPr sz="1100" b="1">
+                <a:solidFill>
+                  <a:srgbClr val="EF4444"/>
+                </a:solidFill>
+              </a:defRPr>
+            </a:pPr>
+            <a:r>
+              <a:t>SECURITY &amp; AUTH</a:t>
+            </a:r>
+          </a:p>
+          <a:p>
+            <a:pPr>
+              <a:defRPr sz="1500" b="1">
+                <a:solidFill>
+                  <a:srgbClr val="F1F5F9"/>
+                </a:solidFill>
+              </a:defRPr>
+            </a:pPr>
+            <a:r>
+              <a:t>Werkzeug Hashing &amp; Role Decorators</a:t>
+            </a:r>
+          </a:p>
+        </p:txBody>
+      </p:sp>
+      <p:sp>
+        <p:nvSpPr>
+          <p:cNvPr id="12" name="TextBox 11"/>
+          <p:cNvSpPr txBox="1"/>
+          <p:nvPr/>
+        </p:nvSpPr>
+        <p:spPr>
+          <a:xfrm>
+            <a:off x="4114800" y="4251960"/>
+            <a:ext cx="7040880" cy="640080"/>
+          </a:xfrm>
+          <a:prstGeom prst="rect">
+            <a:avLst/>
+          </a:prstGeom>
+          <a:noFill/>
+        </p:spPr>
+        <p:txBody>
+          <a:bodyPr wrap="square">
+            <a:spAutoFit/>
+          </a:bodyPr>
+          <a:lstStyle/>
+          <a:p>
+            <a:pPr>
               <a:defRPr sz="1300">
                 <a:solidFill>
-                  <a:srgbClr val="F1F5F9"/>
-                </a:solidFill>
-              </a:defRPr>
-            </a:pPr>
-            <a:r>
-              <a:t>Select date, view full class roster, mark status via toggles, submit single bulk transaction.</a:t>
-            </a:r>
-          </a:p>
-        </p:txBody>
-      </p:sp>
-      <p:sp>
-        <p:nvSpPr>
-          <p:cNvPr id="10" name="Rounded Rectangle 9"/>
+                  <a:srgbClr val="94A3B8"/>
+                </a:solidFill>
+              </a:defRPr>
+            </a:pPr>
+            <a:r>
+              <a:t>Scrypt password hashing, session management, `@admin_required`, `@teacher_required`, `@student_required`.</a:t>
+            </a:r>
+          </a:p>
+        </p:txBody>
+      </p:sp>
+      <p:sp>
+        <p:nvSpPr>
+          <p:cNvPr id="13" name="Rounded Rectangle 12"/>
           <p:cNvSpPr/>
           <p:nvPr/>
         </p:nvSpPr>
         <p:spPr>
           <a:xfrm>
-            <a:off x="8961120" y="2011680"/>
-            <a:ext cx="2468880" cy="4023360"/>
+            <a:off x="731520" y="5212080"/>
+            <a:ext cx="10698480" cy="1005840"/>
           </a:xfrm>
           <a:prstGeom prst="roundRect">
             <a:avLst/>
@@ -5999,14 +5664,14 @@
       </p:sp>
       <p:sp>
         <p:nvSpPr>
-          <p:cNvPr id="11" name="TextBox 10"/>
+          <p:cNvPr id="14" name="TextBox 13"/>
           <p:cNvSpPr txBox="1"/>
           <p:nvPr/>
         </p:nvSpPr>
         <p:spPr>
           <a:xfrm>
-            <a:off x="9098280" y="2194560"/>
-            <a:ext cx="2194560" cy="3657600"/>
+            <a:off x="1005840" y="5349240"/>
+            <a:ext cx="2926080" cy="731520"/>
           </a:xfrm>
           <a:prstGeom prst="rect">
             <a:avLst/>
@@ -6020,29 +5685,61 @@
           <a:lstStyle/>
           <a:p>
             <a:pPr>
-              <a:defRPr sz="1600" b="1">
-                <a:solidFill>
-                  <a:srgbClr val="0EA5E9"/>
-                </a:solidFill>
-              </a:defRPr>
-            </a:pPr>
-            <a:r>
-              <a:t>4. Real-time Analysis</a:t>
-            </a:r>
-          </a:p>
-          <a:p>
-            <a:pPr>
-              <a:spcBef>
-                <a:spcPts val="1600"/>
-              </a:spcBef>
+              <a:defRPr sz="1100" b="1">
+                <a:solidFill>
+                  <a:srgbClr val="6366F1"/>
+                </a:solidFill>
+              </a:defRPr>
+            </a:pPr>
+            <a:r>
+              <a:t>FRONTEND &amp; STYLING</a:t>
+            </a:r>
+          </a:p>
+          <a:p>
+            <a:pPr>
+              <a:defRPr sz="1500" b="1">
+                <a:solidFill>
+                  <a:srgbClr val="F1F5F9"/>
+                </a:solidFill>
+              </a:defRPr>
+            </a:pPr>
+            <a:r>
+              <a:t>HTML5, Vanilla CSS &amp; Bootstrap 5</a:t>
+            </a:r>
+          </a:p>
+        </p:txBody>
+      </p:sp>
+      <p:sp>
+        <p:nvSpPr>
+          <p:cNvPr id="15" name="TextBox 14"/>
+          <p:cNvSpPr txBox="1"/>
+          <p:nvPr/>
+        </p:nvSpPr>
+        <p:spPr>
+          <a:xfrm>
+            <a:off x="4114800" y="5440680"/>
+            <a:ext cx="7040880" cy="640080"/>
+          </a:xfrm>
+          <a:prstGeom prst="rect">
+            <a:avLst/>
+          </a:prstGeom>
+          <a:noFill/>
+        </p:spPr>
+        <p:txBody>
+          <a:bodyPr wrap="square">
+            <a:spAutoFit/>
+          </a:bodyPr>
+          <a:lstStyle/>
+          <a:p>
+            <a:pPr>
               <a:defRPr sz="1300">
                 <a:solidFill>
-                  <a:srgbClr val="F1F5F9"/>
-                </a:solidFill>
-              </a:defRPr>
-            </a:pPr>
-            <a:r>
-              <a:t>Dashboard instantly recalculates statistics &amp; attendance records log reflects new updates.</a:t>
+                  <a:srgbClr val="94A3B8"/>
+                </a:solidFill>
+              </a:defRPr>
+            </a:pPr>
+            <a:r>
+              <a:t>Modern glassmorphism UI, Outfit/Plus Jakarta typography, animated counter numbers.</a:t>
             </a:r>
           </a:p>
         </p:txBody>
@@ -6098,13 +5795,13 @@
             <a:pPr>
               <a:defRPr sz="1100" b="1">
                 <a:solidFill>
-                  <a:srgbClr val="0EA5E9"/>
+                  <a:srgbClr val="3B82F6"/>
                 </a:solidFill>
                 <a:latin typeface="Calibri"/>
               </a:defRPr>
             </a:pPr>
             <a:r>
-              <a:t>MARKMATE ATTENDANCE SYSTEM</a:t>
+              <a:t>MARKMATE MULTI-PORTAL ATTENDANCE SYSTEM</a:t>
             </a:r>
           </a:p>
         </p:txBody>
@@ -6140,7 +5837,7 @@
               </a:defRPr>
             </a:pPr>
             <a:r>
-              <a:t>Future Enhancements &amp; Roadmap</a:t>
+              <a:t>Database Schema &amp; Relational Models</a:t>
             </a:r>
           </a:p>
         </p:txBody>
@@ -6154,7 +5851,7 @@
         <p:spPr>
           <a:xfrm>
             <a:off x="731520" y="1645920"/>
-            <a:ext cx="5120640" cy="2194560"/>
+            <a:ext cx="3383280" cy="4572000"/>
           </a:xfrm>
           <a:prstGeom prst="roundRect">
             <a:avLst/>
@@ -6198,8 +5895,8 @@
         </p:nvSpPr>
         <p:spPr>
           <a:xfrm>
-            <a:off x="1005840" y="1920240"/>
-            <a:ext cx="4572000" cy="1645920"/>
+            <a:off x="914400" y="1828800"/>
+            <a:ext cx="3017520" cy="4114800"/>
           </a:xfrm>
           <a:prstGeom prst="rect">
             <a:avLst/>
@@ -6213,29 +5910,134 @@
           <a:lstStyle/>
           <a:p>
             <a:pPr>
-              <a:defRPr sz="1700" b="1">
-                <a:solidFill>
-                  <a:srgbClr val="0EA5E9"/>
-                </a:solidFill>
-              </a:defRPr>
-            </a:pPr>
-            <a:r>
-              <a:t>📁 Automated Export Reports</a:t>
+              <a:defRPr sz="1800" b="1">
+                <a:solidFill>
+                  <a:srgbClr val="6366F1"/>
+                </a:solidFill>
+              </a:defRPr>
+            </a:pPr>
+            <a:r>
+              <a:t>Teacher Entity</a:t>
             </a:r>
           </a:p>
           <a:p>
             <a:pPr>
               <a:spcBef>
-                <a:spcPts val="1000"/>
+                <a:spcPts val="400"/>
               </a:spcBef>
-              <a:defRPr sz="1300">
+              <a:defRPr sz="1200" b="1">
+                <a:solidFill>
+                  <a:srgbClr val="94A3B8"/>
+                </a:solidFill>
+              </a:defRPr>
+            </a:pPr>
+            <a:r>
+              <a:t>Table: `teachers`</a:t>
+            </a:r>
+          </a:p>
+          <a:p>
+            <a:pPr>
+              <a:spcBef>
+                <a:spcPts val="1200"/>
+              </a:spcBef>
+              <a:defRPr sz="1300" b="1">
                 <a:solidFill>
                   <a:srgbClr val="F1F5F9"/>
                 </a:solidFill>
               </a:defRPr>
             </a:pPr>
             <a:r>
-              <a:t>Download daily/monthly attendance history into formatted CSV, Excel, or PDF reports for academic audits.</a:t>
+              <a:t>Attributes:</a:t>
+            </a:r>
+          </a:p>
+          <a:p>
+            <a:pPr>
+              <a:spcBef>
+                <a:spcPts val="600"/>
+              </a:spcBef>
+              <a:defRPr sz="1200">
+                <a:solidFill>
+                  <a:srgbClr val="F1F5F9"/>
+                </a:solidFill>
+              </a:defRPr>
+            </a:pPr>
+            <a:r>
+              <a:t>• id (PK, Integer)</a:t>
+            </a:r>
+          </a:p>
+          <a:p>
+            <a:pPr>
+              <a:spcBef>
+                <a:spcPts val="600"/>
+              </a:spcBef>
+              <a:defRPr sz="1200">
+                <a:solidFill>
+                  <a:srgbClr val="F1F5F9"/>
+                </a:solidFill>
+              </a:defRPr>
+            </a:pPr>
+            <a:r>
+              <a:t>• username (Unique)</a:t>
+            </a:r>
+          </a:p>
+          <a:p>
+            <a:pPr>
+              <a:spcBef>
+                <a:spcPts val="600"/>
+              </a:spcBef>
+              <a:defRPr sz="1200">
+                <a:solidFill>
+                  <a:srgbClr val="F1F5F9"/>
+                </a:solidFill>
+              </a:defRPr>
+            </a:pPr>
+            <a:r>
+              <a:t>• password (Hashed)</a:t>
+            </a:r>
+          </a:p>
+          <a:p>
+            <a:pPr>
+              <a:spcBef>
+                <a:spcPts val="600"/>
+              </a:spcBef>
+              <a:defRPr sz="1200">
+                <a:solidFill>
+                  <a:srgbClr val="F1F5F9"/>
+                </a:solidFill>
+              </a:defRPr>
+            </a:pPr>
+            <a:r>
+              <a:t>• name (String)</a:t>
+            </a:r>
+          </a:p>
+          <a:p>
+            <a:pPr>
+              <a:spcBef>
+                <a:spcPts val="600"/>
+              </a:spcBef>
+              <a:defRPr sz="1200">
+                <a:solidFill>
+                  <a:srgbClr val="F1F5F9"/>
+                </a:solidFill>
+              </a:defRPr>
+            </a:pPr>
+            <a:r>
+              <a:t>• department (String)</a:t>
+            </a:r>
+          </a:p>
+          <a:p>
+            <a:pPr>
+              <a:spcBef>
+                <a:spcPts val="600"/>
+              </a:spcBef>
+              <a:defRPr sz="1200">
+                <a:solidFill>
+                  <a:srgbClr val="F1F5F9"/>
+                </a:solidFill>
+              </a:defRPr>
+            </a:pPr>
+            <a:r>
+              <a:t>• email (String)</a:t>
             </a:r>
           </a:p>
         </p:txBody>
@@ -6248,8 +6050,8 @@
         </p:nvSpPr>
         <p:spPr>
           <a:xfrm>
-            <a:off x="6309360" y="1645920"/>
-            <a:ext cx="5120640" cy="2194560"/>
+            <a:off x="4389120" y="1645920"/>
+            <a:ext cx="3383280" cy="4572000"/>
           </a:xfrm>
           <a:prstGeom prst="roundRect">
             <a:avLst/>
@@ -6293,8 +6095,8 @@
         </p:nvSpPr>
         <p:spPr>
           <a:xfrm>
-            <a:off x="6583680" y="1920240"/>
-            <a:ext cx="4572000" cy="1645920"/>
+            <a:off x="4572000" y="1828800"/>
+            <a:ext cx="3017520" cy="4114800"/>
           </a:xfrm>
           <a:prstGeom prst="rect">
             <a:avLst/>
@@ -6308,29 +6110,134 @@
           <a:lstStyle/>
           <a:p>
             <a:pPr>
-              <a:defRPr sz="1700" b="1">
-                <a:solidFill>
-                  <a:srgbClr val="F43F5E"/>
-                </a:solidFill>
-              </a:defRPr>
-            </a:pPr>
-            <a:r>
-              <a:t>⚠️ Threshold &amp; Low-Attendance Alerts</a:t>
+              <a:defRPr sz="1800" b="1">
+                <a:solidFill>
+                  <a:srgbClr val="10B981"/>
+                </a:solidFill>
+              </a:defRPr>
+            </a:pPr>
+            <a:r>
+              <a:t>Student Entity</a:t>
             </a:r>
           </a:p>
           <a:p>
             <a:pPr>
               <a:spcBef>
-                <a:spcPts val="1000"/>
+                <a:spcPts val="400"/>
               </a:spcBef>
-              <a:defRPr sz="1300">
+              <a:defRPr sz="1200" b="1">
+                <a:solidFill>
+                  <a:srgbClr val="94A3B8"/>
+                </a:solidFill>
+              </a:defRPr>
+            </a:pPr>
+            <a:r>
+              <a:t>Table: `students`</a:t>
+            </a:r>
+          </a:p>
+          <a:p>
+            <a:pPr>
+              <a:spcBef>
+                <a:spcPts val="1200"/>
+              </a:spcBef>
+              <a:defRPr sz="1300" b="1">
                 <a:solidFill>
                   <a:srgbClr val="F1F5F9"/>
                 </a:solidFill>
               </a:defRPr>
             </a:pPr>
             <a:r>
-              <a:t>Automatic warning flags &amp; notifications for students dropping below mandatory thresholds (e.g. &lt; 75%).</a:t>
+              <a:t>Attributes:</a:t>
+            </a:r>
+          </a:p>
+          <a:p>
+            <a:pPr>
+              <a:spcBef>
+                <a:spcPts val="600"/>
+              </a:spcBef>
+              <a:defRPr sz="1200">
+                <a:solidFill>
+                  <a:srgbClr val="F1F5F9"/>
+                </a:solidFill>
+              </a:defRPr>
+            </a:pPr>
+            <a:r>
+              <a:t>• id (PK, Integer)</a:t>
+            </a:r>
+          </a:p>
+          <a:p>
+            <a:pPr>
+              <a:spcBef>
+                <a:spcPts val="600"/>
+              </a:spcBef>
+              <a:defRPr sz="1200">
+                <a:solidFill>
+                  <a:srgbClr val="F1F5F9"/>
+                </a:solidFill>
+              </a:defRPr>
+            </a:pPr>
+            <a:r>
+              <a:t>• roll_number (Unique)</a:t>
+            </a:r>
+          </a:p>
+          <a:p>
+            <a:pPr>
+              <a:spcBef>
+                <a:spcPts val="600"/>
+              </a:spcBef>
+              <a:defRPr sz="1200">
+                <a:solidFill>
+                  <a:srgbClr val="F1F5F9"/>
+                </a:solidFill>
+              </a:defRPr>
+            </a:pPr>
+            <a:r>
+              <a:t>• name (String)</a:t>
+            </a:r>
+          </a:p>
+          <a:p>
+            <a:pPr>
+              <a:spcBef>
+                <a:spcPts val="600"/>
+              </a:spcBef>
+              <a:defRPr sz="1200">
+                <a:solidFill>
+                  <a:srgbClr val="F1F5F9"/>
+                </a:solidFill>
+              </a:defRPr>
+            </a:pPr>
+            <a:r>
+              <a:t>• department (String)</a:t>
+            </a:r>
+          </a:p>
+          <a:p>
+            <a:pPr>
+              <a:spcBef>
+                <a:spcPts val="600"/>
+              </a:spcBef>
+              <a:defRPr sz="1200">
+                <a:solidFill>
+                  <a:srgbClr val="F1F5F9"/>
+                </a:solidFill>
+              </a:defRPr>
+            </a:pPr>
+            <a:r>
+              <a:t>• semester (String)</a:t>
+            </a:r>
+          </a:p>
+          <a:p>
+            <a:pPr>
+              <a:spcBef>
+                <a:spcPts val="600"/>
+              </a:spcBef>
+              <a:defRPr sz="1200">
+                <a:solidFill>
+                  <a:srgbClr val="F1F5F9"/>
+                </a:solidFill>
+              </a:defRPr>
+            </a:pPr>
+            <a:r>
+              <a:t>• password (Hashed)</a:t>
             </a:r>
           </a:p>
         </p:txBody>
@@ -6343,8 +6250,8 @@
         </p:nvSpPr>
         <p:spPr>
           <a:xfrm>
-            <a:off x="731520" y="4114800"/>
-            <a:ext cx="5120640" cy="2194560"/>
+            <a:off x="8046720" y="1645920"/>
+            <a:ext cx="3383280" cy="4572000"/>
           </a:xfrm>
           <a:prstGeom prst="roundRect">
             <a:avLst/>
@@ -6388,8 +6295,8 @@
         </p:nvSpPr>
         <p:spPr>
           <a:xfrm>
-            <a:off x="1005840" y="4389120"/>
-            <a:ext cx="4572000" cy="1645920"/>
+            <a:off x="8229600" y="1828800"/>
+            <a:ext cx="3017520" cy="4114800"/>
           </a:xfrm>
           <a:prstGeom prst="rect">
             <a:avLst/>
@@ -6403,124 +6310,119 @@
           <a:lstStyle/>
           <a:p>
             <a:pPr>
-              <a:defRPr sz="1700" b="1">
-                <a:solidFill>
-                  <a:srgbClr val="10B981"/>
-                </a:solidFill>
-              </a:defRPr>
-            </a:pPr>
-            <a:r>
-              <a:t>📱 Student &amp; Parent Portal</a:t>
+              <a:defRPr sz="1800" b="1">
+                <a:solidFill>
+                  <a:srgbClr val="EF4444"/>
+                </a:solidFill>
+              </a:defRPr>
+            </a:pPr>
+            <a:r>
+              <a:t>Attendance Entity</a:t>
             </a:r>
           </a:p>
           <a:p>
             <a:pPr>
               <a:spcBef>
-                <a:spcPts val="1000"/>
+                <a:spcPts val="400"/>
               </a:spcBef>
-              <a:defRPr sz="1300">
+              <a:defRPr sz="1200" b="1">
+                <a:solidFill>
+                  <a:srgbClr val="94A3B8"/>
+                </a:solidFill>
+              </a:defRPr>
+            </a:pPr>
+            <a:r>
+              <a:t>Table: `attendance`</a:t>
+            </a:r>
+          </a:p>
+          <a:p>
+            <a:pPr>
+              <a:spcBef>
+                <a:spcPts val="1200"/>
+              </a:spcBef>
+              <a:defRPr sz="1300" b="1">
                 <a:solidFill>
                   <a:srgbClr val="F1F5F9"/>
                 </a:solidFill>
               </a:defRPr>
             </a:pPr>
             <a:r>
-              <a:t>Dedicated student dashboard view allowing individual self-check of attendance history &amp; subject percentage.</a:t>
-            </a:r>
-          </a:p>
-        </p:txBody>
-      </p:sp>
-      <p:sp>
-        <p:nvSpPr>
-          <p:cNvPr id="10" name="Rounded Rectangle 9"/>
-          <p:cNvSpPr/>
-          <p:nvPr/>
-        </p:nvSpPr>
-        <p:spPr>
-          <a:xfrm>
-            <a:off x="6309360" y="4114800"/>
-            <a:ext cx="5120640" cy="2194560"/>
-          </a:xfrm>
-          <a:prstGeom prst="roundRect">
-            <a:avLst/>
-          </a:prstGeom>
-          <a:solidFill>
-            <a:srgbClr val="1E293B"/>
-          </a:solidFill>
-          <a:ln>
-            <a:solidFill>
-              <a:srgbClr val="1E293B"/>
-            </a:solidFill>
-          </a:ln>
-        </p:spPr>
-        <p:style>
-          <a:lnRef idx="1">
-            <a:schemeClr val="accent1"/>
-          </a:lnRef>
-          <a:fillRef idx="3">
-            <a:schemeClr val="accent1"/>
-          </a:fillRef>
-          <a:effectRef idx="2">
-            <a:schemeClr val="accent1"/>
-          </a:effectRef>
-          <a:fontRef idx="minor">
-            <a:schemeClr val="lt1"/>
-          </a:fontRef>
-        </p:style>
-        <p:txBody>
-          <a:bodyPr rtlCol="0" anchor="ctr"/>
-          <a:lstStyle/>
-          <a:p>
-            <a:pPr algn="ctr"/>
-          </a:p>
-        </p:txBody>
-      </p:sp>
-      <p:sp>
-        <p:nvSpPr>
-          <p:cNvPr id="11" name="TextBox 10"/>
-          <p:cNvSpPr txBox="1"/>
-          <p:nvPr/>
-        </p:nvSpPr>
-        <p:spPr>
-          <a:xfrm>
-            <a:off x="6583680" y="4389120"/>
-            <a:ext cx="4572000" cy="1645920"/>
-          </a:xfrm>
-          <a:prstGeom prst="rect">
-            <a:avLst/>
-          </a:prstGeom>
-          <a:noFill/>
-        </p:spPr>
-        <p:txBody>
-          <a:bodyPr wrap="square">
-            <a:spAutoFit/>
-          </a:bodyPr>
-          <a:lstStyle/>
-          <a:p>
-            <a:pPr>
-              <a:defRPr sz="1700" b="1">
-                <a:solidFill>
-                  <a:srgbClr val="0EA5E9"/>
-                </a:solidFill>
-              </a:defRPr>
-            </a:pPr>
-            <a:r>
-              <a:t>📸 Dynamic QR &amp; AI Attendance</a:t>
+              <a:t>Attributes:</a:t>
             </a:r>
           </a:p>
           <a:p>
             <a:pPr>
               <a:spcBef>
-                <a:spcPts val="1000"/>
+                <a:spcPts val="600"/>
               </a:spcBef>
-              <a:defRPr sz="1300">
+              <a:defRPr sz="1200">
                 <a:solidFill>
                   <a:srgbClr val="F1F5F9"/>
                 </a:solidFill>
               </a:defRPr>
             </a:pPr>
             <a:r>
-              <a:t>Integration with facial recognition or dynamic QR codes projected in class for automated zero-contact attendance.</a:t>
+              <a:t>• id (PK, Integer)</a:t>
+            </a:r>
+          </a:p>
+          <a:p>
+            <a:pPr>
+              <a:spcBef>
+                <a:spcPts val="600"/>
+              </a:spcBef>
+              <a:defRPr sz="1200">
+                <a:solidFill>
+                  <a:srgbClr val="F1F5F9"/>
+                </a:solidFill>
+              </a:defRPr>
+            </a:pPr>
+            <a:r>
+              <a:t>• student_id (FK)</a:t>
+            </a:r>
+          </a:p>
+          <a:p>
+            <a:pPr>
+              <a:spcBef>
+                <a:spcPts val="600"/>
+              </a:spcBef>
+              <a:defRPr sz="1200">
+                <a:solidFill>
+                  <a:srgbClr val="F1F5F9"/>
+                </a:solidFill>
+              </a:defRPr>
+            </a:pPr>
+            <a:r>
+              <a:t>• attendance_date (Date)</a:t>
+            </a:r>
+          </a:p>
+          <a:p>
+            <a:pPr>
+              <a:spcBef>
+                <a:spcPts val="600"/>
+              </a:spcBef>
+              <a:defRPr sz="1200">
+                <a:solidFill>
+                  <a:srgbClr val="F1F5F9"/>
+                </a:solidFill>
+              </a:defRPr>
+            </a:pPr>
+            <a:r>
+              <a:t>• status ('Present'/'Absent')</a:t>
+            </a:r>
+          </a:p>
+          <a:p>
+            <a:pPr>
+              <a:spcBef>
+                <a:spcPts val="600"/>
+              </a:spcBef>
+              <a:defRPr sz="1200">
+                <a:solidFill>
+                  <a:srgbClr val="F1F5F9"/>
+                </a:solidFill>
+              </a:defRPr>
+            </a:pPr>
+            <a:r>
+              <a:t>• Unique(student_id, date)</a:t>
             </a:r>
           </a:p>
         </p:txBody>
@@ -6553,14 +6455,86 @@
       <p:grpSpPr/>
       <p:sp>
         <p:nvSpPr>
-          <p:cNvPr id="2" name="Rounded Rectangle 1"/>
+          <p:cNvPr id="2" name="TextBox 1"/>
+          <p:cNvSpPr txBox="1"/>
+          <p:nvPr/>
+        </p:nvSpPr>
+        <p:spPr>
+          <a:xfrm>
+            <a:off x="731520" y="365760"/>
+            <a:ext cx="10698480" cy="365760"/>
+          </a:xfrm>
+          <a:prstGeom prst="rect">
+            <a:avLst/>
+          </a:prstGeom>
+          <a:noFill/>
+        </p:spPr>
+        <p:txBody>
+          <a:bodyPr wrap="square">
+            <a:spAutoFit/>
+          </a:bodyPr>
+          <a:lstStyle/>
+          <a:p>
+            <a:pPr>
+              <a:defRPr sz="1100" b="1">
+                <a:solidFill>
+                  <a:srgbClr val="3B82F6"/>
+                </a:solidFill>
+                <a:latin typeface="Calibri"/>
+              </a:defRPr>
+            </a:pPr>
+            <a:r>
+              <a:t>MARKMATE MULTI-PORTAL ATTENDANCE SYSTEM</a:t>
+            </a:r>
+          </a:p>
+        </p:txBody>
+      </p:sp>
+      <p:sp>
+        <p:nvSpPr>
+          <p:cNvPr id="3" name="TextBox 2"/>
+          <p:cNvSpPr txBox="1"/>
+          <p:nvPr/>
+        </p:nvSpPr>
+        <p:spPr>
+          <a:xfrm>
+            <a:off x="731520" y="685800"/>
+            <a:ext cx="10698480" cy="731520"/>
+          </a:xfrm>
+          <a:prstGeom prst="rect">
+            <a:avLst/>
+          </a:prstGeom>
+          <a:noFill/>
+        </p:spPr>
+        <p:txBody>
+          <a:bodyPr wrap="square">
+            <a:spAutoFit/>
+          </a:bodyPr>
+          <a:lstStyle/>
+          <a:p>
+            <a:pPr>
+              <a:defRPr sz="2600" b="1">
+                <a:solidFill>
+                  <a:srgbClr val="F1F5F9"/>
+                </a:solidFill>
+                <a:latin typeface="Calibri"/>
+              </a:defRPr>
+            </a:pPr>
+            <a:r>
+              <a:t>Future Roadmap &amp; Project Scaling</a:t>
+            </a:r>
+          </a:p>
+        </p:txBody>
+      </p:sp>
+      <p:sp>
+        <p:nvSpPr>
+          <p:cNvPr id="4" name="Rounded Rectangle 3"/>
           <p:cNvSpPr/>
           <p:nvPr/>
         </p:nvSpPr>
         <p:spPr>
           <a:xfrm>
-            <a:off x="1371600" y="1371600"/>
-            <a:ext cx="9448495" cy="4114800"/>
+            <a:off x="731520" y="1645920"/>
+            <a:ext cx="5120640" cy="2194560"/>
           </a:xfrm>
           <a:prstGeom prst="roundRect">
             <a:avLst/>
@@ -6598,14 +6572,14 @@
       </p:sp>
       <p:sp>
         <p:nvSpPr>
-          <p:cNvPr id="3" name="TextBox 2"/>
+          <p:cNvPr id="5" name="TextBox 4"/>
           <p:cNvSpPr txBox="1"/>
           <p:nvPr/>
         </p:nvSpPr>
         <p:spPr>
           <a:xfrm>
-            <a:off x="1828800" y="1828800"/>
-            <a:ext cx="8534095" cy="3200400"/>
+            <a:off x="1005840" y="1920240"/>
+            <a:ext cx="4572000" cy="1645920"/>
           </a:xfrm>
           <a:prstGeom prst="rect">
             <a:avLst/>
@@ -6618,10 +6592,416 @@
           </a:bodyPr>
           <a:lstStyle/>
           <a:p>
+            <a:pPr>
+              <a:defRPr sz="1700" b="1">
+                <a:solidFill>
+                  <a:srgbClr val="3B82F6"/>
+                </a:solidFill>
+              </a:defRPr>
+            </a:pPr>
+            <a:r>
+              <a:t>📲 Automated SMS / WhatsApp Alerts</a:t>
+            </a:r>
+          </a:p>
+          <a:p>
+            <a:pPr>
+              <a:spcBef>
+                <a:spcPts val="1000"/>
+              </a:spcBef>
+              <a:defRPr sz="1300">
+                <a:solidFill>
+                  <a:srgbClr val="F1F5F9"/>
+                </a:solidFill>
+              </a:defRPr>
+            </a:pPr>
+            <a:r>
+              <a:t>Instant automated WhatsApp alerts to parents when student attendance drops below 75%.</a:t>
+            </a:r>
+          </a:p>
+        </p:txBody>
+      </p:sp>
+      <p:sp>
+        <p:nvSpPr>
+          <p:cNvPr id="6" name="Rounded Rectangle 5"/>
+          <p:cNvSpPr/>
+          <p:nvPr/>
+        </p:nvSpPr>
+        <p:spPr>
+          <a:xfrm>
+            <a:off x="6309360" y="1645920"/>
+            <a:ext cx="5120640" cy="2194560"/>
+          </a:xfrm>
+          <a:prstGeom prst="roundRect">
+            <a:avLst/>
+          </a:prstGeom>
+          <a:solidFill>
+            <a:srgbClr val="1E293B"/>
+          </a:solidFill>
+          <a:ln>
+            <a:solidFill>
+              <a:srgbClr val="1E293B"/>
+            </a:solidFill>
+          </a:ln>
+        </p:spPr>
+        <p:style>
+          <a:lnRef idx="1">
+            <a:schemeClr val="accent1"/>
+          </a:lnRef>
+          <a:fillRef idx="3">
+            <a:schemeClr val="accent1"/>
+          </a:fillRef>
+          <a:effectRef idx="2">
+            <a:schemeClr val="accent1"/>
+          </a:effectRef>
+          <a:fontRef idx="minor">
+            <a:schemeClr val="lt1"/>
+          </a:fontRef>
+        </p:style>
+        <p:txBody>
+          <a:bodyPr rtlCol="0" anchor="ctr"/>
+          <a:lstStyle/>
+          <a:p>
+            <a:pPr algn="ctr"/>
+          </a:p>
+        </p:txBody>
+      </p:sp>
+      <p:sp>
+        <p:nvSpPr>
+          <p:cNvPr id="7" name="TextBox 6"/>
+          <p:cNvSpPr txBox="1"/>
+          <p:nvPr/>
+        </p:nvSpPr>
+        <p:spPr>
+          <a:xfrm>
+            <a:off x="6583680" y="1920240"/>
+            <a:ext cx="4572000" cy="1645920"/>
+          </a:xfrm>
+          <a:prstGeom prst="rect">
+            <a:avLst/>
+          </a:prstGeom>
+          <a:noFill/>
+        </p:spPr>
+        <p:txBody>
+          <a:bodyPr wrap="square">
+            <a:spAutoFit/>
+          </a:bodyPr>
+          <a:lstStyle/>
+          <a:p>
+            <a:pPr>
+              <a:defRPr sz="1700" b="1">
+                <a:solidFill>
+                  <a:srgbClr val="EF4444"/>
+                </a:solidFill>
+              </a:defRPr>
+            </a:pPr>
+            <a:r>
+              <a:t>📸 AI Biometric / Facial Recognition</a:t>
+            </a:r>
+          </a:p>
+          <a:p>
+            <a:pPr>
+              <a:spcBef>
+                <a:spcPts val="1000"/>
+              </a:spcBef>
+              <a:defRPr sz="1300">
+                <a:solidFill>
+                  <a:srgbClr val="F1F5F9"/>
+                </a:solidFill>
+              </a:defRPr>
+            </a:pPr>
+            <a:r>
+              <a:t>Zero-touch classroom attendance marking via camera face recognition model.</a:t>
+            </a:r>
+          </a:p>
+        </p:txBody>
+      </p:sp>
+      <p:sp>
+        <p:nvSpPr>
+          <p:cNvPr id="8" name="Rounded Rectangle 7"/>
+          <p:cNvSpPr/>
+          <p:nvPr/>
+        </p:nvSpPr>
+        <p:spPr>
+          <a:xfrm>
+            <a:off x="731520" y="4114800"/>
+            <a:ext cx="5120640" cy="2194560"/>
+          </a:xfrm>
+          <a:prstGeom prst="roundRect">
+            <a:avLst/>
+          </a:prstGeom>
+          <a:solidFill>
+            <a:srgbClr val="1E293B"/>
+          </a:solidFill>
+          <a:ln>
+            <a:solidFill>
+              <a:srgbClr val="1E293B"/>
+            </a:solidFill>
+          </a:ln>
+        </p:spPr>
+        <p:style>
+          <a:lnRef idx="1">
+            <a:schemeClr val="accent1"/>
+          </a:lnRef>
+          <a:fillRef idx="3">
+            <a:schemeClr val="accent1"/>
+          </a:fillRef>
+          <a:effectRef idx="2">
+            <a:schemeClr val="accent1"/>
+          </a:effectRef>
+          <a:fontRef idx="minor">
+            <a:schemeClr val="lt1"/>
+          </a:fontRef>
+        </p:style>
+        <p:txBody>
+          <a:bodyPr rtlCol="0" anchor="ctr"/>
+          <a:lstStyle/>
+          <a:p>
+            <a:pPr algn="ctr"/>
+          </a:p>
+        </p:txBody>
+      </p:sp>
+      <p:sp>
+        <p:nvSpPr>
+          <p:cNvPr id="9" name="TextBox 8"/>
+          <p:cNvSpPr txBox="1"/>
+          <p:nvPr/>
+        </p:nvSpPr>
+        <p:spPr>
+          <a:xfrm>
+            <a:off x="1005840" y="4389120"/>
+            <a:ext cx="4572000" cy="1645920"/>
+          </a:xfrm>
+          <a:prstGeom prst="rect">
+            <a:avLst/>
+          </a:prstGeom>
+          <a:noFill/>
+        </p:spPr>
+        <p:txBody>
+          <a:bodyPr wrap="square">
+            <a:spAutoFit/>
+          </a:bodyPr>
+          <a:lstStyle/>
+          <a:p>
+            <a:pPr>
+              <a:defRPr sz="1700" b="1">
+                <a:solidFill>
+                  <a:srgbClr val="10B981"/>
+                </a:solidFill>
+              </a:defRPr>
+            </a:pPr>
+            <a:r>
+              <a:t>📊 Course &amp; Subject-Wise Tracking</a:t>
+            </a:r>
+          </a:p>
+          <a:p>
+            <a:pPr>
+              <a:spcBef>
+                <a:spcPts val="1000"/>
+              </a:spcBef>
+              <a:defRPr sz="1300">
+                <a:solidFill>
+                  <a:srgbClr val="F1F5F9"/>
+                </a:solidFill>
+              </a:defRPr>
+            </a:pPr>
+            <a:r>
+              <a:t>Granular attendance tracking per individual course subject code and lecture time.</a:t>
+            </a:r>
+          </a:p>
+        </p:txBody>
+      </p:sp>
+      <p:sp>
+        <p:nvSpPr>
+          <p:cNvPr id="10" name="Rounded Rectangle 9"/>
+          <p:cNvSpPr/>
+          <p:nvPr/>
+        </p:nvSpPr>
+        <p:spPr>
+          <a:xfrm>
+            <a:off x="6309360" y="4114800"/>
+            <a:ext cx="5120640" cy="2194560"/>
+          </a:xfrm>
+          <a:prstGeom prst="roundRect">
+            <a:avLst/>
+          </a:prstGeom>
+          <a:solidFill>
+            <a:srgbClr val="1E293B"/>
+          </a:solidFill>
+          <a:ln>
+            <a:solidFill>
+              <a:srgbClr val="1E293B"/>
+            </a:solidFill>
+          </a:ln>
+        </p:spPr>
+        <p:style>
+          <a:lnRef idx="1">
+            <a:schemeClr val="accent1"/>
+          </a:lnRef>
+          <a:fillRef idx="3">
+            <a:schemeClr val="accent1"/>
+          </a:fillRef>
+          <a:effectRef idx="2">
+            <a:schemeClr val="accent1"/>
+          </a:effectRef>
+          <a:fontRef idx="minor">
+            <a:schemeClr val="lt1"/>
+          </a:fontRef>
+        </p:style>
+        <p:txBody>
+          <a:bodyPr rtlCol="0" anchor="ctr"/>
+          <a:lstStyle/>
+          <a:p>
+            <a:pPr algn="ctr"/>
+          </a:p>
+        </p:txBody>
+      </p:sp>
+      <p:sp>
+        <p:nvSpPr>
+          <p:cNvPr id="11" name="TextBox 10"/>
+          <p:cNvSpPr txBox="1"/>
+          <p:nvPr/>
+        </p:nvSpPr>
+        <p:spPr>
+          <a:xfrm>
+            <a:off x="6583680" y="4389120"/>
+            <a:ext cx="4572000" cy="1645920"/>
+          </a:xfrm>
+          <a:prstGeom prst="rect">
+            <a:avLst/>
+          </a:prstGeom>
+          <a:noFill/>
+        </p:spPr>
+        <p:txBody>
+          <a:bodyPr wrap="square">
+            <a:spAutoFit/>
+          </a:bodyPr>
+          <a:lstStyle/>
+          <a:p>
+            <a:pPr>
+              <a:defRPr sz="1700" b="1">
+                <a:solidFill>
+                  <a:srgbClr val="6366F1"/>
+                </a:solidFill>
+              </a:defRPr>
+            </a:pPr>
+            <a:r>
+              <a:t>📱 Native Mobile Application</a:t>
+            </a:r>
+          </a:p>
+          <a:p>
+            <a:pPr>
+              <a:spcBef>
+                <a:spcPts val="1000"/>
+              </a:spcBef>
+              <a:defRPr sz="1300">
+                <a:solidFill>
+                  <a:srgbClr val="F1F5F9"/>
+                </a:solidFill>
+              </a:defRPr>
+            </a:pPr>
+            <a:r>
+              <a:t>iOS &amp; Android mobile apps with push notifications for instant attendance updates.</a:t>
+            </a:r>
+          </a:p>
+        </p:txBody>
+      </p:sp>
+    </p:spTree>
+  </p:cSld>
+  <p:clrMapOvr>
+    <a:masterClrMapping/>
+  </p:clrMapOvr>
+</p:sld>
+</file>
+
+<file path=ppt/slides/slide9.xml><?xml version="1.0" encoding="utf-8"?>
+<p:sld xmlns:a="http://schemas.openxmlformats.org/drawingml/2006/main" xmlns:p="http://schemas.openxmlformats.org/presentationml/2006/main" xmlns:r="http://schemas.openxmlformats.org/officeDocument/2006/relationships">
+  <p:cSld>
+    <p:bg>
+      <p:bgPr>
+        <a:solidFill>
+          <a:srgbClr val="0F172A"/>
+        </a:solidFill>
+        <a:effectLst/>
+      </p:bgPr>
+    </p:bg>
+    <p:spTree>
+      <p:nvGrpSpPr>
+        <p:cNvPr id="1" name=""/>
+        <p:cNvGrpSpPr/>
+        <p:nvPr/>
+      </p:nvGrpSpPr>
+      <p:grpSpPr/>
+      <p:sp>
+        <p:nvSpPr>
+          <p:cNvPr id="2" name="Rounded Rectangle 1"/>
+          <p:cNvSpPr/>
+          <p:nvPr/>
+        </p:nvSpPr>
+        <p:spPr>
+          <a:xfrm>
+            <a:off x="1371600" y="1371600"/>
+            <a:ext cx="9448495" cy="4114800"/>
+          </a:xfrm>
+          <a:prstGeom prst="roundRect">
+            <a:avLst/>
+          </a:prstGeom>
+          <a:solidFill>
+            <a:srgbClr val="1E293B"/>
+          </a:solidFill>
+          <a:ln>
+            <a:solidFill>
+              <a:srgbClr val="1E293B"/>
+            </a:solidFill>
+          </a:ln>
+        </p:spPr>
+        <p:style>
+          <a:lnRef idx="1">
+            <a:schemeClr val="accent1"/>
+          </a:lnRef>
+          <a:fillRef idx="3">
+            <a:schemeClr val="accent1"/>
+          </a:fillRef>
+          <a:effectRef idx="2">
+            <a:schemeClr val="accent1"/>
+          </a:effectRef>
+          <a:fontRef idx="minor">
+            <a:schemeClr val="lt1"/>
+          </a:fontRef>
+        </p:style>
+        <p:txBody>
+          <a:bodyPr rtlCol="0" anchor="ctr"/>
+          <a:lstStyle/>
+          <a:p>
+            <a:pPr algn="ctr"/>
+          </a:p>
+        </p:txBody>
+      </p:sp>
+      <p:sp>
+        <p:nvSpPr>
+          <p:cNvPr id="3" name="TextBox 2"/>
+          <p:cNvSpPr txBox="1"/>
+          <p:nvPr/>
+        </p:nvSpPr>
+        <p:spPr>
+          <a:xfrm>
+            <a:off x="1828800" y="1828800"/>
+            <a:ext cx="8534095" cy="3200400"/>
+          </a:xfrm>
+          <a:prstGeom prst="rect">
+            <a:avLst/>
+          </a:prstGeom>
+          <a:noFill/>
+        </p:spPr>
+        <p:txBody>
+          <a:bodyPr wrap="square">
+            <a:spAutoFit/>
+          </a:bodyPr>
+          <a:lstStyle/>
+          <a:p>
             <a:pPr algn="ctr">
-              <a:defRPr sz="4000" b="1">
-                <a:solidFill>
-                  <a:srgbClr val="0EA5E9"/>
+              <a:defRPr sz="4200" b="1">
+                <a:solidFill>
+                  <a:srgbClr val="3B82F6"/>
                 </a:solidFill>
               </a:defRPr>
             </a:pPr>
@@ -6641,7 +7021,7 @@
               </a:defRPr>
             </a:pPr>
             <a:r>
-              <a:t>MarkMate - Automated Student Attendance Management System</a:t>
+              <a:t>MarkMate • Multi-Portal Student Attendance &amp; Department System</a:t>
             </a:r>
           </a:p>
           <a:p>

</xml_diff>